<commit_message>
Qualys CI lookup rules V3.2: lists inline in rules 420/430/460, no custom properties; deck and workbook aligned
Co-Authored-By: Claude Fable 5.1 <noreply@anthropic.com>
Claude-Session: https://claude.ai/code/session_01UaiSzs85tKmfaeLA1rAxsP
</commit_message>
<xml_diff>
--- a/stories/qualys-ci-lookup-rules/Qualys CI Lookup Rules - Technical Walkthrough.pptx
+++ b/stories/qualys-ci-lookup-rules/Qualys CI Lookup Rules - Technical Walkthrough.pptx
@@ -3477,7 +3477,7 @@
           <a:p>
             <a:r>
               <a:rPr lang="en-US" dirty="0"/>
-              <a:t>The values shown are the defaults shipped with the rules; each rule falls back to them if its property is missing.</a:t>
+              <a:t>These are the lists as shipped; each sits at the top of the matching stage in its rule script.</a:t>
             </a:r>
             <a:endParaRPr lang="en-US" dirty="0"/>
           </a:p>
@@ -3829,7 +3829,7 @@
           <a:p>
             <a:r>
               <a:rPr lang="en-US" dirty="0"/>
-              <a:t>The last point is the operational guardrail: watch the matched share per rule after any property change.</a:t>
+              <a:t>The last point is the operational guardrail: watch the matched share per rule after any list change.</a:t>
             </a:r>
             <a:endParaRPr lang="en-US" dirty="0"/>
           </a:p>
@@ -5212,7 +5212,7 @@
                 <a:ea typeface="Arial" pitchFamily="34" charset="-122"/>
                 <a:cs typeface="Arial" pitchFamily="34" charset="-120"/>
               </a:rPr>
-              <a:t>6</a:t>
+              <a:t>5</a:t>
             </a:r>
             <a:endParaRPr lang="en-US" sz="4200" dirty="0"/>
           </a:p>
@@ -5251,7 +5251,7 @@
                 <a:ea typeface="Arial" pitchFamily="34" charset="-122"/>
                 <a:cs typeface="Arial" pitchFamily="34" charset="-120"/>
               </a:rPr>
-              <a:t>property lists, no code to change</a:t>
+              <a:t>principles shared by every rule</a:t>
             </a:r>
             <a:endParaRPr lang="en-US" sz="1200" dirty="0"/>
           </a:p>
@@ -28297,7 +28297,7 @@
                 <a:ea typeface="Arial" pitchFamily="34" charset="-122"/>
                 <a:cs typeface="Arial" pitchFamily="34" charset="-120"/>
               </a:rPr>
-              <a:t>labels ending in a listed suffix, or a controller named in the OS text.</a:t>
+              <a:t>labels ending in one of the controller suffixes, or a controller named in the OS text; both lists are in the script.</a:t>
             </a:r>
             <a:endParaRPr lang="en-US" sz="950" dirty="0"/>
           </a:p>
@@ -28829,11 +28829,11 @@
         <p:spPr>
           <a:xfrm>
             <a:off x="457200" y="2121408"/>
-            <a:ext cx="11274552" cy="1094842"/>
+            <a:ext cx="11274552" cy="1170432"/>
           </a:xfrm>
           <a:prstGeom prst="roundRect">
             <a:avLst>
-              <a:gd name="adj" fmla="val 4176"/>
+              <a:gd name="adj" fmla="val 3906"/>
             </a:avLst>
           </a:prstGeom>
           <a:solidFill>
@@ -28862,7 +28862,7 @@
         </p:nvSpPr>
         <p:spPr>
           <a:xfrm>
-            <a:off x="658368" y="2540813"/>
+            <a:off x="658368" y="2578608"/>
             <a:ext cx="256032" cy="256032"/>
           </a:xfrm>
           <a:prstGeom prst="roundRect">
@@ -28889,7 +28889,7 @@
         </p:nvSpPr>
         <p:spPr>
           <a:xfrm>
-            <a:off x="658368" y="2540813"/>
+            <a:off x="658368" y="2578608"/>
             <a:ext cx="256032" cy="256032"/>
           </a:xfrm>
           <a:prstGeom prst="rect">
@@ -28929,7 +28929,7 @@
         <p:spPr>
           <a:xfrm>
             <a:off x="1005840" y="2212848"/>
-            <a:ext cx="3246120" cy="911962"/>
+            <a:ext cx="3246120" cy="987552"/>
           </a:xfrm>
           <a:prstGeom prst="rect">
             <a:avLst/>
@@ -28973,7 +28973,7 @@
                 <a:ea typeface="Arial" pitchFamily="34" charset="-122"/>
                 <a:cs typeface="Arial" pitchFamily="34" charset="-120"/>
               </a:rPr>
-              <a:t>Plenty of ordinary server names contain hyphens. Without this check the prefix walk would strip real hostnames and could land on an unrelated device.</a:t>
+              <a:t>Plenty of ordinary server names contain hyphens. Without this check the prefix walk would strip real hostnames and could land on an unrelated device. The two lists sit right here in the script.</a:t>
             </a:r>
             <a:endParaRPr lang="en-US" sz="1200" dirty="0"/>
           </a:p>
@@ -28987,12 +28987,12 @@
         </p:nvSpPr>
         <p:spPr>
           <a:xfrm>
-            <a:off x="4617720" y="2293925"/>
-            <a:ext cx="6949440" cy="749808"/>
+            <a:off x="4617720" y="2390242"/>
+            <a:ext cx="6949440" cy="632765"/>
           </a:xfrm>
           <a:prstGeom prst="roundRect">
             <a:avLst>
-              <a:gd name="adj" fmla="val 4878"/>
+              <a:gd name="adj" fmla="val 5780"/>
             </a:avLst>
           </a:prstGeom>
           <a:solidFill>
@@ -29014,8 +29014,8 @@
         </p:nvSpPr>
         <p:spPr>
           <a:xfrm>
-            <a:off x="4727448" y="2367077"/>
-            <a:ext cx="6729984" cy="603504"/>
+            <a:off x="4727448" y="2463394"/>
+            <a:ext cx="6729984" cy="486461"/>
           </a:xfrm>
           <a:prstGeom prst="rect">
             <a:avLst/>
@@ -29042,7 +29042,7 @@
                 <a:ea typeface="Courier New" pitchFamily="34" charset="-122"/>
                 <a:cs typeface="Courier New" pitchFamily="34" charset="-120"/>
               </a:rPr>
-              <a:t>var domains = list('usem.ci_lookup.interface_domains',</a:t>
+              <a:t>var domains = ['.network.'];</a:t>
             </a:r>
             <a:endParaRPr lang="en-US" sz="800" dirty="0"/>
           </a:p>
@@ -29062,7 +29062,7 @@
                 <a:ea typeface="Courier New" pitchFamily="34" charset="-122"/>
                 <a:cs typeface="Courier New" pitchFamily="34" charset="-120"/>
               </a:rPr>
-              <a:t>                   '.network.');</a:t>
+              <a:t>var markers = ['vlan', 'v', 'hsrp', 'vrrp', 'po', 'eth',</a:t>
             </a:r>
             <a:endParaRPr lang="en-US" sz="800" dirty="0"/>
           </a:p>
@@ -29082,7 +29082,7 @@
                 <a:ea typeface="Courier New" pitchFamily="34" charset="-122"/>
                 <a:cs typeface="Courier New" pitchFamily="34" charset="-120"/>
               </a:rPr>
-              <a:t>var markers = list('usem.ci_lookup.interface_markers',</a:t>
+              <a:t>               'gi', 'te', 'lo', 'mgmt', 'aom', 'vs', 'fab'];</a:t>
             </a:r>
             <a:endParaRPr lang="en-US" sz="800" dirty="0"/>
           </a:p>
@@ -29102,26 +29102,6 @@
                 <a:ea typeface="Courier New" pitchFamily="34" charset="-122"/>
                 <a:cs typeface="Courier New" pitchFamily="34" charset="-120"/>
               </a:rPr>
-              <a:t>                   'vlan,v,hsrp,vrrp,po,eth,gi,te,lo,aom,vs');</a:t>
-            </a:r>
-            <a:endParaRPr lang="en-US" sz="800" dirty="0"/>
-          </a:p>
-          <a:p>
-            <a:pPr indent="0" marL="0">
-              <a:lnSpc>
-                <a:spcPct val="94000"/>
-              </a:lnSpc>
-              <a:buNone/>
-            </a:pPr>
-            <a:r>
-              <a:rPr lang="en-US" sz="800" dirty="0">
-                <a:solidFill>
-                  <a:srgbClr val="E9EBED"/>
-                </a:solidFill>
-                <a:latin typeface="Courier New" pitchFamily="34" charset="0"/>
-                <a:ea typeface="Courier New" pitchFamily="34" charset="-122"/>
-                <a:cs typeface="Courier New" pitchFamily="34" charset="-120"/>
-              </a:rPr>
               <a:t>if (!evidence) return null;</a:t>
             </a:r>
             <a:endParaRPr lang="en-US" sz="800" dirty="0"/>
@@ -29136,12 +29116,12 @@
         </p:nvSpPr>
         <p:spPr>
           <a:xfrm>
-            <a:off x="457200" y="3307690"/>
-            <a:ext cx="11274552" cy="1208227"/>
+            <a:off x="457200" y="3383280"/>
+            <a:ext cx="11274552" cy="1170432"/>
           </a:xfrm>
           <a:prstGeom prst="roundRect">
             <a:avLst>
-              <a:gd name="adj" fmla="val 3784"/>
+              <a:gd name="adj" fmla="val 3906"/>
             </a:avLst>
           </a:prstGeom>
           <a:solidFill>
@@ -29170,7 +29150,7 @@
         </p:nvSpPr>
         <p:spPr>
           <a:xfrm>
-            <a:off x="658368" y="3783787"/>
+            <a:off x="658368" y="3840480"/>
             <a:ext cx="256032" cy="256032"/>
           </a:xfrm>
           <a:prstGeom prst="roundRect">
@@ -29197,7 +29177,7 @@
         </p:nvSpPr>
         <p:spPr>
           <a:xfrm>
-            <a:off x="658368" y="3783787"/>
+            <a:off x="658368" y="3840480"/>
             <a:ext cx="256032" cy="256032"/>
           </a:xfrm>
           <a:prstGeom prst="rect">
@@ -29236,8 +29216,8 @@
         </p:nvSpPr>
         <p:spPr>
           <a:xfrm>
-            <a:off x="1005840" y="3399130"/>
-            <a:ext cx="3246120" cy="1025347"/>
+            <a:off x="1005840" y="3474720"/>
+            <a:ext cx="3246120" cy="987552"/>
           </a:xfrm>
           <a:prstGeom prst="rect">
             <a:avLst/>
@@ -29295,7 +29275,7 @@
         </p:nvSpPr>
         <p:spPr>
           <a:xfrm>
-            <a:off x="4617720" y="3536899"/>
+            <a:off x="4617720" y="3593592"/>
             <a:ext cx="6949440" cy="749808"/>
           </a:xfrm>
           <a:prstGeom prst="roundRect">
@@ -29322,7 +29302,7 @@
         </p:nvSpPr>
         <p:spPr>
           <a:xfrm>
-            <a:off x="4727448" y="3610051"/>
+            <a:off x="4727448" y="3666744"/>
             <a:ext cx="6729984" cy="603504"/>
           </a:xfrm>
           <a:prstGeom prst="rect">
@@ -29495,12 +29475,12 @@
         </p:nvSpPr>
         <p:spPr>
           <a:xfrm>
-            <a:off x="457200" y="4607357"/>
-            <a:ext cx="11274552" cy="1208227"/>
+            <a:off x="457200" y="4645152"/>
+            <a:ext cx="11274552" cy="1170432"/>
           </a:xfrm>
           <a:prstGeom prst="roundRect">
             <a:avLst>
-              <a:gd name="adj" fmla="val 3784"/>
+              <a:gd name="adj" fmla="val 3906"/>
             </a:avLst>
           </a:prstGeom>
           <a:solidFill>
@@ -29529,7 +29509,7 @@
         </p:nvSpPr>
         <p:spPr>
           <a:xfrm>
-            <a:off x="658368" y="5083454"/>
+            <a:off x="658368" y="5102352"/>
             <a:ext cx="256032" cy="256032"/>
           </a:xfrm>
           <a:prstGeom prst="roundRect">
@@ -29556,7 +29536,7 @@
         </p:nvSpPr>
         <p:spPr>
           <a:xfrm>
-            <a:off x="658368" y="5083454"/>
+            <a:off x="658368" y="5102352"/>
             <a:ext cx="256032" cy="256032"/>
           </a:xfrm>
           <a:prstGeom prst="rect">
@@ -29595,8 +29575,8 @@
         </p:nvSpPr>
         <p:spPr>
           <a:xfrm>
-            <a:off x="1005840" y="4698797"/>
-            <a:ext cx="3246120" cy="1025347"/>
+            <a:off x="1005840" y="4736592"/>
+            <a:ext cx="3246120" cy="987552"/>
           </a:xfrm>
           <a:prstGeom prst="rect">
             <a:avLst/>
@@ -29654,7 +29634,7 @@
         </p:nvSpPr>
         <p:spPr>
           <a:xfrm>
-            <a:off x="4617720" y="4895088"/>
+            <a:off x="4617720" y="4913986"/>
             <a:ext cx="6949440" cy="632765"/>
           </a:xfrm>
           <a:prstGeom prst="roundRect">
@@ -29681,7 +29661,7 @@
         </p:nvSpPr>
         <p:spPr>
           <a:xfrm>
-            <a:off x="4727448" y="4968240"/>
+            <a:off x="4727448" y="4987138"/>
             <a:ext cx="6729984" cy="486461"/>
           </a:xfrm>
           <a:prstGeom prst="rect">
@@ -29942,7 +29922,7 @@
                 <a:ea typeface="Arial" pitchFamily="34" charset="-122"/>
                 <a:cs typeface="Arial" pitchFamily="34" charset="-120"/>
               </a:rPr>
-              <a:t>labels under an interface domain, or carrying a marker segment.</a:t>
+              <a:t>labels under an interface domain, or carrying a marker segment; both lists are in the script.</a:t>
             </a:r>
             <a:endParaRPr lang="en-US" sz="950" dirty="0"/>
           </a:p>
@@ -31851,11 +31831,11 @@
         <p:spPr>
           <a:xfrm>
             <a:off x="457200" y="2121408"/>
-            <a:ext cx="11274552" cy="1189939"/>
+            <a:ext cx="11274552" cy="1265530"/>
           </a:xfrm>
           <a:prstGeom prst="roundRect">
             <a:avLst>
-              <a:gd name="adj" fmla="val 3842"/>
+              <a:gd name="adj" fmla="val 3613"/>
             </a:avLst>
           </a:prstGeom>
           <a:solidFill>
@@ -31884,7 +31864,7 @@
         </p:nvSpPr>
         <p:spPr>
           <a:xfrm>
-            <a:off x="658368" y="2588362"/>
+            <a:off x="658368" y="2626157"/>
             <a:ext cx="256032" cy="256032"/>
           </a:xfrm>
           <a:prstGeom prst="roundRect">
@@ -31911,7 +31891,7 @@
         </p:nvSpPr>
         <p:spPr>
           <a:xfrm>
-            <a:off x="658368" y="2588362"/>
+            <a:off x="658368" y="2626157"/>
             <a:ext cx="256032" cy="256032"/>
           </a:xfrm>
           <a:prstGeom prst="rect">
@@ -31951,7 +31931,7 @@
         <p:spPr>
           <a:xfrm>
             <a:off x="1005840" y="2212848"/>
-            <a:ext cx="3246120" cy="1007059"/>
+            <a:ext cx="3246120" cy="1082650"/>
           </a:xfrm>
           <a:prstGeom prst="rect">
             <a:avLst/>
@@ -31995,7 +31975,7 @@
                 <a:ea typeface="Arial" pitchFamily="34" charset="-122"/>
                 <a:cs typeface="Arial" pitchFamily="34" charset="-120"/>
               </a:rPr>
-              <a:t>A Load Balancer Service must never be returned for an ordinary server that happens to share an address with a VIP.</a:t>
+              <a:t>A Load Balancer Service must never be returned for an ordinary server that happens to share an address with a VIP. The two lists sit right here in the script.</a:t>
             </a:r>
             <a:endParaRPr lang="en-US" sz="1200" dirty="0"/>
           </a:p>
@@ -32009,12 +31989,12 @@
         </p:nvSpPr>
         <p:spPr>
           <a:xfrm>
-            <a:off x="4617720" y="2341474"/>
-            <a:ext cx="6949440" cy="749808"/>
+            <a:off x="4617720" y="2496312"/>
+            <a:ext cx="6949440" cy="515722"/>
           </a:xfrm>
           <a:prstGeom prst="roundRect">
             <a:avLst>
-              <a:gd name="adj" fmla="val 4878"/>
+              <a:gd name="adj" fmla="val 7092"/>
             </a:avLst>
           </a:prstGeom>
           <a:solidFill>
@@ -32036,8 +32016,8 @@
         </p:nvSpPr>
         <p:spPr>
           <a:xfrm>
-            <a:off x="4727448" y="2414626"/>
-            <a:ext cx="6729984" cy="603504"/>
+            <a:off x="4727448" y="2569464"/>
+            <a:ext cx="6729984" cy="369418"/>
           </a:xfrm>
           <a:prstGeom prst="rect">
             <a:avLst/>
@@ -32064,7 +32044,7 @@
                 <a:ea typeface="Courier New" pitchFamily="34" charset="-122"/>
                 <a:cs typeface="Courier New" pitchFamily="34" charset="-120"/>
               </a:rPr>
-              <a:t>var osMarkers = list('usem.ci_lookup.vip_os_markers',</a:t>
+              <a:t>var osMarkers = ['f5', 'big-ip', 'big ip', 'netscaler'];</a:t>
             </a:r>
             <a:endParaRPr lang="en-US" sz="800" dirty="0"/>
           </a:p>
@@ -32084,7 +32064,7 @@
                 <a:ea typeface="Courier New" pitchFamily="34" charset="-122"/>
                 <a:cs typeface="Courier New" pitchFamily="34" charset="-120"/>
               </a:rPr>
-              <a:t>                     'f5,big-ip,big ip,netscaler');</a:t>
+              <a:t>var labelMarkers = ['vip', 'vs'];</a:t>
             </a:r>
             <a:endParaRPr lang="en-US" sz="800" dirty="0"/>
           </a:p>
@@ -32104,46 +32084,6 @@
                 <a:ea typeface="Courier New" pitchFamily="34" charset="-122"/>
                 <a:cs typeface="Courier New" pitchFamily="34" charset="-120"/>
               </a:rPr>
-              <a:t>var labelMarkers = list('usem.ci_lookup.vip_markers',</a:t>
-            </a:r>
-            <a:endParaRPr lang="en-US" sz="800" dirty="0"/>
-          </a:p>
-          <a:p>
-            <a:pPr indent="0" marL="0">
-              <a:lnSpc>
-                <a:spcPct val="94000"/>
-              </a:lnSpc>
-              <a:buNone/>
-            </a:pPr>
-            <a:r>
-              <a:rPr lang="en-US" sz="800" dirty="0">
-                <a:solidFill>
-                  <a:srgbClr val="E9EBED"/>
-                </a:solidFill>
-                <a:latin typeface="Courier New" pitchFamily="34" charset="0"/>
-                <a:ea typeface="Courier New" pitchFamily="34" charset="-122"/>
-                <a:cs typeface="Courier New" pitchFamily="34" charset="-120"/>
-              </a:rPr>
-              <a:t>                        'vip,vs');</a:t>
-            </a:r>
-            <a:endParaRPr lang="en-US" sz="800" dirty="0"/>
-          </a:p>
-          <a:p>
-            <a:pPr indent="0" marL="0">
-              <a:lnSpc>
-                <a:spcPct val="94000"/>
-              </a:lnSpc>
-              <a:buNone/>
-            </a:pPr>
-            <a:r>
-              <a:rPr lang="en-US" sz="800" dirty="0">
-                <a:solidFill>
-                  <a:srgbClr val="E9EBED"/>
-                </a:solidFill>
-                <a:latin typeface="Courier New" pitchFamily="34" charset="0"/>
-                <a:ea typeface="Courier New" pitchFamily="34" charset="-122"/>
-                <a:cs typeface="Courier New" pitchFamily="34" charset="-120"/>
-              </a:rPr>
               <a:t>if (!evidence) return null;</a:t>
             </a:r>
             <a:endParaRPr lang="en-US" sz="800" dirty="0"/>
@@ -32158,12 +32098,12 @@
         </p:nvSpPr>
         <p:spPr>
           <a:xfrm>
-            <a:off x="457200" y="3402787"/>
-            <a:ext cx="11274552" cy="1160678"/>
+            <a:off x="457200" y="3478378"/>
+            <a:ext cx="11274552" cy="1122883"/>
           </a:xfrm>
           <a:prstGeom prst="roundRect">
             <a:avLst>
-              <a:gd name="adj" fmla="val 3939"/>
+              <a:gd name="adj" fmla="val 4072"/>
             </a:avLst>
           </a:prstGeom>
           <a:solidFill>
@@ -32192,7 +32132,7 @@
         </p:nvSpPr>
         <p:spPr>
           <a:xfrm>
-            <a:off x="658368" y="3855110"/>
+            <a:off x="658368" y="3911803"/>
             <a:ext cx="256032" cy="256032"/>
           </a:xfrm>
           <a:prstGeom prst="roundRect">
@@ -32219,7 +32159,7 @@
         </p:nvSpPr>
         <p:spPr>
           <a:xfrm>
-            <a:off x="658368" y="3855110"/>
+            <a:off x="658368" y="3911803"/>
             <a:ext cx="256032" cy="256032"/>
           </a:xfrm>
           <a:prstGeom prst="rect">
@@ -32258,8 +32198,8 @@
         </p:nvSpPr>
         <p:spPr>
           <a:xfrm>
-            <a:off x="1005840" y="3494227"/>
-            <a:ext cx="3246120" cy="977798"/>
+            <a:off x="1005840" y="3569818"/>
+            <a:ext cx="3246120" cy="940003"/>
           </a:xfrm>
           <a:prstGeom prst="rect">
             <a:avLst/>
@@ -32317,7 +32257,7 @@
         </p:nvSpPr>
         <p:spPr>
           <a:xfrm>
-            <a:off x="4617720" y="3666744"/>
+            <a:off x="4617720" y="3723437"/>
             <a:ext cx="6949440" cy="632765"/>
           </a:xfrm>
           <a:prstGeom prst="roundRect">
@@ -32344,7 +32284,7 @@
         </p:nvSpPr>
         <p:spPr>
           <a:xfrm>
-            <a:off x="4727448" y="3739896"/>
+            <a:off x="4727448" y="3796589"/>
             <a:ext cx="6729984" cy="486461"/>
           </a:xfrm>
           <a:prstGeom prst="rect">
@@ -32446,12 +32386,12 @@
         </p:nvSpPr>
         <p:spPr>
           <a:xfrm>
-            <a:off x="457200" y="4654906"/>
-            <a:ext cx="11274552" cy="1160678"/>
+            <a:off x="457200" y="4692701"/>
+            <a:ext cx="11274552" cy="1122883"/>
           </a:xfrm>
           <a:prstGeom prst="roundRect">
             <a:avLst>
-              <a:gd name="adj" fmla="val 3939"/>
+              <a:gd name="adj" fmla="val 4072"/>
             </a:avLst>
           </a:prstGeom>
           <a:solidFill>
@@ -32480,7 +32420,7 @@
         </p:nvSpPr>
         <p:spPr>
           <a:xfrm>
-            <a:off x="658368" y="5107229"/>
+            <a:off x="658368" y="5126126"/>
             <a:ext cx="256032" cy="256032"/>
           </a:xfrm>
           <a:prstGeom prst="roundRect">
@@ -32507,7 +32447,7 @@
         </p:nvSpPr>
         <p:spPr>
           <a:xfrm>
-            <a:off x="658368" y="5107229"/>
+            <a:off x="658368" y="5126126"/>
             <a:ext cx="256032" cy="256032"/>
           </a:xfrm>
           <a:prstGeom prst="rect">
@@ -32546,8 +32486,8 @@
         </p:nvSpPr>
         <p:spPr>
           <a:xfrm>
-            <a:off x="1005840" y="4746346"/>
-            <a:ext cx="3246120" cy="977798"/>
+            <a:off x="1005840" y="4784141"/>
+            <a:ext cx="3246120" cy="940003"/>
           </a:xfrm>
           <a:prstGeom prst="rect">
             <a:avLst/>
@@ -32605,7 +32545,7 @@
         </p:nvSpPr>
         <p:spPr>
           <a:xfrm>
-            <a:off x="4617720" y="4918862"/>
+            <a:off x="4617720" y="4937760"/>
             <a:ext cx="6949440" cy="632765"/>
           </a:xfrm>
           <a:prstGeom prst="roundRect">
@@ -32632,7 +32572,7 @@
         </p:nvSpPr>
         <p:spPr>
           <a:xfrm>
-            <a:off x="4727448" y="4992014"/>
+            <a:off x="4727448" y="5010912"/>
             <a:ext cx="6729984" cy="486461"/>
           </a:xfrm>
           <a:prstGeom prst="rect">
@@ -32910,7 +32850,7 @@
                 <a:ea typeface="Arial" pitchFamily="34" charset="-122"/>
                 <a:cs typeface="Arial" pitchFamily="34" charset="-120"/>
               </a:rPr>
-              <a:t>hosts with a load balancer OS word, or a VIP marker in the label.</a:t>
+              <a:t>hosts with a load balancer OS word, or a VIP marker in the label; both lists are in the script.</a:t>
             </a:r>
             <a:endParaRPr lang="en-US" sz="950" dirty="0"/>
           </a:p>
@@ -41053,7 +40993,7 @@
                 <a:ea typeface="Arial" pitchFamily="34" charset="-122"/>
                 <a:cs typeface="Arial" pitchFamily="34" charset="-120"/>
               </a:rPr>
-              <a:t>Six properties that tune the rules</a:t>
+              <a:t>The lists that drive the new rules</a:t>
             </a:r>
             <a:endParaRPr lang="en-US" sz="1150" dirty="0"/>
           </a:p>
@@ -43936,7 +43876,7 @@
                 <a:ea typeface="Arial" pitchFamily="34" charset="-122"/>
                 <a:cs typeface="Arial" pitchFamily="34" charset="-120"/>
               </a:rPr>
-              <a:t>TUNING</a:t>
+              <a:t>VOCABULARY</a:t>
             </a:r>
             <a:endParaRPr lang="en-US" sz="1050" dirty="0"/>
           </a:p>
@@ -43975,7 +43915,7 @@
                 <a:ea typeface="Arial" pitchFamily="34" charset="-122"/>
                 <a:cs typeface="Arial" pitchFamily="34" charset="-120"/>
               </a:rPr>
-              <a:t>Six properties, so the lists are not in the code</a:t>
+              <a:t>The lists that drive the new rules</a:t>
             </a:r>
             <a:endParaRPr lang="en-US" sz="3000" dirty="0"/>
           </a:p>
@@ -44014,7 +43954,7 @@
                 <a:ea typeface="Arial" pitchFamily="34" charset="-122"/>
                 <a:cs typeface="Arial" pitchFamily="34" charset="-120"/>
               </a:rPr>
-              <a:t>The three new rules each depend on a vocabulary: which suffixes mark a controller, which segments mark an interface, which words name a load balancer. Naming habits differ by site and change over time, so every list is a system property the rule reads at run time.</a:t>
+              <a:t>The three new rules each depend on a vocabulary: which suffixes mark a controller, which segments mark an interface, which words name a load balancer. Each list is declared in the script itself, at the top of the stage that reads it, so a reviewer sees the words beside the code that uses them and nothing outside the rule has to exist for it to run.</a:t>
             </a:r>
             <a:endParaRPr lang="en-US" sz="1200" dirty="0"/>
           </a:p>
@@ -44056,52 +43996,13 @@
       </p:sp>
       <p:sp>
         <p:nvSpPr>
-          <p:cNvPr id="6" name="Text 4"/>
-          <p:cNvSpPr txBox="1"/>
-          <p:nvPr/>
-        </p:nvSpPr>
-        <p:spPr>
-          <a:xfrm>
-            <a:off x="658368" y="1865376"/>
-            <a:ext cx="3200400" cy="256032"/>
-          </a:xfrm>
-          <a:prstGeom prst="rect">
-            <a:avLst/>
-          </a:prstGeom>
-          <a:noFill/>
-          <a:ln/>
-        </p:spPr>
-        <p:txBody>
-          <a:bodyPr wrap="square" lIns="0" tIns="0" rIns="0" bIns="0" rtlCol="0" anchor="ctr"/>
-          <a:lstStyle/>
-          <a:p>
-            <a:pPr indent="0" marL="0">
-              <a:buNone/>
-            </a:pPr>
-            <a:r>
-              <a:rPr lang="en-US" sz="1000" b="1" dirty="0">
-                <a:solidFill>
-                  <a:srgbClr val="E31837"/>
-                </a:solidFill>
-                <a:latin typeface="Courier New" pitchFamily="34" charset="0"/>
-                <a:ea typeface="Courier New" pitchFamily="34" charset="-122"/>
-                <a:cs typeface="Courier New" pitchFamily="34" charset="-120"/>
-              </a:rPr>
-              <a:t>usem.ci_lookup.mgmt_suffixes</a:t>
-            </a:r>
-            <a:endParaRPr lang="en-US" sz="1000" dirty="0"/>
-          </a:p>
-        </p:txBody>
-      </p:sp>
-      <p:sp>
-        <p:nvSpPr>
-          <p:cNvPr id="7" name="Shape 5"/>
+          <p:cNvPr id="6" name="Shape 4"/>
           <p:cNvSpPr/>
           <p:nvPr/>
         </p:nvSpPr>
         <p:spPr>
           <a:xfrm>
-            <a:off x="3913632" y="1874520"/>
+            <a:off x="658368" y="1874520"/>
             <a:ext cx="457200" cy="237744"/>
           </a:xfrm>
           <a:prstGeom prst="roundRect">
@@ -44122,116 +44023,155 @@
       </p:sp>
       <p:sp>
         <p:nvSpPr>
+          <p:cNvPr id="7" name="Text 5"/>
+          <p:cNvSpPr txBox="1"/>
+          <p:nvPr/>
+        </p:nvSpPr>
+        <p:spPr>
+          <a:xfrm>
+            <a:off x="658368" y="1874520"/>
+            <a:ext cx="457200" cy="237744"/>
+          </a:xfrm>
+          <a:prstGeom prst="rect">
+            <a:avLst/>
+          </a:prstGeom>
+          <a:noFill/>
+          <a:ln/>
+        </p:spPr>
+        <p:txBody>
+          <a:bodyPr wrap="square" lIns="0" tIns="0" rIns="0" bIns="0" rtlCol="0" anchor="ctr"/>
+          <a:lstStyle/>
+          <a:p>
+            <a:pPr algn="ctr" indent="0" marL="0">
+              <a:buNone/>
+            </a:pPr>
+            <a:r>
+              <a:rPr lang="en-US" sz="1300" b="1" dirty="0">
+                <a:solidFill>
+                  <a:srgbClr val="FFFFFF"/>
+                </a:solidFill>
+                <a:latin typeface="Arial" pitchFamily="34" charset="0"/>
+                <a:ea typeface="Arial" pitchFamily="34" charset="-122"/>
+                <a:cs typeface="Arial" pitchFamily="34" charset="-120"/>
+              </a:rPr>
+              <a:t>420</a:t>
+            </a:r>
+            <a:endParaRPr lang="en-US" sz="1300" dirty="0"/>
+          </a:p>
+        </p:txBody>
+      </p:sp>
+      <p:sp>
+        <p:nvSpPr>
           <p:cNvPr id="8" name="Text 6"/>
           <p:cNvSpPr txBox="1"/>
           <p:nvPr/>
         </p:nvSpPr>
         <p:spPr>
           <a:xfrm>
-            <a:off x="3913632" y="1874520"/>
-            <a:ext cx="457200" cy="237744"/>
-          </a:xfrm>
-          <a:prstGeom prst="rect">
-            <a:avLst/>
-          </a:prstGeom>
-          <a:noFill/>
-          <a:ln/>
-        </p:spPr>
-        <p:txBody>
-          <a:bodyPr wrap="square" lIns="0" tIns="0" rIns="0" bIns="0" rtlCol="0" anchor="ctr"/>
-          <a:lstStyle/>
-          <a:p>
-            <a:pPr algn="ctr" indent="0" marL="0">
-              <a:buNone/>
-            </a:pPr>
-            <a:r>
-              <a:rPr lang="en-US" sz="1300" b="1" dirty="0">
-                <a:solidFill>
-                  <a:srgbClr val="FFFFFF"/>
-                </a:solidFill>
-                <a:latin typeface="Arial" pitchFamily="34" charset="0"/>
-                <a:ea typeface="Arial" pitchFamily="34" charset="-122"/>
-                <a:cs typeface="Arial" pitchFamily="34" charset="-120"/>
-              </a:rPr>
-              <a:t>420</a:t>
-            </a:r>
-            <a:endParaRPr lang="en-US" sz="1300" dirty="0"/>
-          </a:p>
-        </p:txBody>
-      </p:sp>
-      <p:sp>
-        <p:nvSpPr>
-          <p:cNvPr id="9" name="Text 7"/>
-          <p:cNvSpPr txBox="1"/>
-          <p:nvPr/>
-        </p:nvSpPr>
-        <p:spPr>
-          <a:xfrm>
-            <a:off x="4498848" y="1865376"/>
-            <a:ext cx="6949440" cy="256032"/>
-          </a:xfrm>
-          <a:prstGeom prst="rect">
-            <a:avLst/>
-          </a:prstGeom>
-          <a:noFill/>
-          <a:ln/>
-        </p:spPr>
-        <p:txBody>
-          <a:bodyPr wrap="square" lIns="0" tIns="0" rIns="0" bIns="0" rtlCol="0" anchor="ctr"/>
-          <a:lstStyle/>
-          <a:p>
-            <a:pPr indent="0" marL="0">
-              <a:buNone/>
-            </a:pPr>
-            <a:r>
-              <a:rPr lang="en-US" sz="1000" dirty="0">
-                <a:solidFill>
-                  <a:srgbClr val="24272A"/>
-                </a:solidFill>
-                <a:latin typeface="Arial" pitchFamily="34" charset="0"/>
-                <a:ea typeface="Arial" pitchFamily="34" charset="-122"/>
-                <a:cs typeface="Arial" pitchFamily="34" charset="-120"/>
-              </a:rPr>
-              <a:t>Label suffixes that mark a management controller.</a:t>
-            </a:r>
-            <a:endParaRPr lang="en-US" sz="1000" dirty="0"/>
-          </a:p>
-        </p:txBody>
-      </p:sp>
-      <p:sp>
-        <p:nvSpPr>
-          <p:cNvPr id="10" name="Text 8"/>
-          <p:cNvSpPr txBox="1"/>
-          <p:nvPr/>
-        </p:nvSpPr>
-        <p:spPr>
-          <a:xfrm>
-            <a:off x="658368" y="2139696"/>
-            <a:ext cx="10789920" cy="237744"/>
-          </a:xfrm>
-          <a:prstGeom prst="rect">
-            <a:avLst/>
-          </a:prstGeom>
-          <a:noFill/>
-          <a:ln/>
-        </p:spPr>
-        <p:txBody>
-          <a:bodyPr wrap="square" lIns="0" tIns="0" rIns="0" bIns="0" rtlCol="0" anchor="ctr"/>
-          <a:lstStyle/>
-          <a:p>
-            <a:pPr indent="0" marL="0">
-              <a:buNone/>
-            </a:pPr>
-            <a:r>
-              <a:rPr lang="en-US" sz="900" dirty="0">
-                <a:solidFill>
-                  <a:srgbClr val="6B7177"/>
+            <a:off x="1243584" y="1865376"/>
+            <a:ext cx="2377440" cy="256032"/>
+          </a:xfrm>
+          <a:prstGeom prst="rect">
+            <a:avLst/>
+          </a:prstGeom>
+          <a:noFill/>
+          <a:ln/>
+        </p:spPr>
+        <p:txBody>
+          <a:bodyPr wrap="square" lIns="0" tIns="0" rIns="0" bIns="0" rtlCol="0" anchor="ctr"/>
+          <a:lstStyle/>
+          <a:p>
+            <a:pPr indent="0" marL="0">
+              <a:buNone/>
+            </a:pPr>
+            <a:r>
+              <a:rPr lang="en-US" sz="1000" b="1" dirty="0">
+                <a:solidFill>
+                  <a:srgbClr val="E31837"/>
                 </a:solidFill>
                 <a:latin typeface="Courier New" pitchFamily="34" charset="0"/>
                 <a:ea typeface="Courier New" pitchFamily="34" charset="-122"/>
                 <a:cs typeface="Courier New" pitchFamily="34" charset="-120"/>
               </a:rPr>
-              <a:t>ilo, ilom, idrac, drac, ipmi, bmc, oob, mgmt, imm, cimc, rmm, con</a:t>
+              <a:t>var suffixes</a:t>
+            </a:r>
+            <a:endParaRPr lang="en-US" sz="1000" dirty="0"/>
+          </a:p>
+        </p:txBody>
+      </p:sp>
+      <p:sp>
+        <p:nvSpPr>
+          <p:cNvPr id="9" name="Text 7"/>
+          <p:cNvSpPr txBox="1"/>
+          <p:nvPr/>
+        </p:nvSpPr>
+        <p:spPr>
+          <a:xfrm>
+            <a:off x="3749040" y="1865376"/>
+            <a:ext cx="7680960" cy="256032"/>
+          </a:xfrm>
+          <a:prstGeom prst="rect">
+            <a:avLst/>
+          </a:prstGeom>
+          <a:noFill/>
+          <a:ln/>
+        </p:spPr>
+        <p:txBody>
+          <a:bodyPr wrap="square" lIns="0" tIns="0" rIns="0" bIns="0" rtlCol="0" anchor="ctr"/>
+          <a:lstStyle/>
+          <a:p>
+            <a:pPr indent="0" marL="0">
+              <a:buNone/>
+            </a:pPr>
+            <a:r>
+              <a:rPr lang="en-US" sz="1000" dirty="0">
+                <a:solidFill>
+                  <a:srgbClr val="24272A"/>
+                </a:solidFill>
+                <a:latin typeface="Arial" pitchFamily="34" charset="0"/>
+                <a:ea typeface="Arial" pitchFamily="34" charset="-122"/>
+                <a:cs typeface="Arial" pitchFamily="34" charset="-120"/>
+              </a:rPr>
+              <a:t>Label suffixes that mark a management controller.</a:t>
+            </a:r>
+            <a:endParaRPr lang="en-US" sz="1000" dirty="0"/>
+          </a:p>
+        </p:txBody>
+      </p:sp>
+      <p:sp>
+        <p:nvSpPr>
+          <p:cNvPr id="10" name="Text 8"/>
+          <p:cNvSpPr txBox="1"/>
+          <p:nvPr/>
+        </p:nvSpPr>
+        <p:spPr>
+          <a:xfrm>
+            <a:off x="1243584" y="2139696"/>
+            <a:ext cx="10241280" cy="237744"/>
+          </a:xfrm>
+          <a:prstGeom prst="rect">
+            <a:avLst/>
+          </a:prstGeom>
+          <a:noFill/>
+          <a:ln/>
+        </p:spPr>
+        <p:txBody>
+          <a:bodyPr wrap="square" lIns="0" tIns="0" rIns="0" bIns="0" rtlCol="0" anchor="ctr"/>
+          <a:lstStyle/>
+          <a:p>
+            <a:pPr indent="0" marL="0">
+              <a:buNone/>
+            </a:pPr>
+            <a:r>
+              <a:rPr lang="en-US" sz="900" dirty="0">
+                <a:solidFill>
+                  <a:srgbClr val="6B7177"/>
+                </a:solidFill>
+                <a:latin typeface="Courier New" pitchFamily="34" charset="0"/>
+                <a:ea typeface="Courier New" pitchFamily="34" charset="-122"/>
+                <a:cs typeface="Courier New" pitchFamily="34" charset="-120"/>
+              </a:rPr>
+              <a:t>['ilo', 'ilom', 'idrac', 'drac', 'ipmi', 'bmc', 'oob', 'mgmt', 'imm', 'cimc', 'rmm', 'con']</a:t>
             </a:r>
             <a:endParaRPr lang="en-US" sz="900" dirty="0"/>
           </a:p>
@@ -44273,52 +44213,13 @@
       </p:sp>
       <p:sp>
         <p:nvSpPr>
-          <p:cNvPr id="12" name="Text 10"/>
-          <p:cNvSpPr txBox="1"/>
-          <p:nvPr/>
-        </p:nvSpPr>
-        <p:spPr>
-          <a:xfrm>
-            <a:off x="658368" y="2578608"/>
-            <a:ext cx="3200400" cy="256032"/>
-          </a:xfrm>
-          <a:prstGeom prst="rect">
-            <a:avLst/>
-          </a:prstGeom>
-          <a:noFill/>
-          <a:ln/>
-        </p:spPr>
-        <p:txBody>
-          <a:bodyPr wrap="square" lIns="0" tIns="0" rIns="0" bIns="0" rtlCol="0" anchor="ctr"/>
-          <a:lstStyle/>
-          <a:p>
-            <a:pPr indent="0" marL="0">
-              <a:buNone/>
-            </a:pPr>
-            <a:r>
-              <a:rPr lang="en-US" sz="1000" b="1" dirty="0">
-                <a:solidFill>
-                  <a:srgbClr val="E31837"/>
-                </a:solidFill>
-                <a:latin typeface="Courier New" pitchFamily="34" charset="0"/>
-                <a:ea typeface="Courier New" pitchFamily="34" charset="-122"/>
-                <a:cs typeface="Courier New" pitchFamily="34" charset="-120"/>
-              </a:rPr>
-              <a:t>usem.ci_lookup.mgmt_os_markers</a:t>
-            </a:r>
-            <a:endParaRPr lang="en-US" sz="1000" dirty="0"/>
-          </a:p>
-        </p:txBody>
-      </p:sp>
-      <p:sp>
-        <p:nvSpPr>
-          <p:cNvPr id="13" name="Shape 11"/>
+          <p:cNvPr id="12" name="Shape 10"/>
           <p:cNvSpPr/>
           <p:nvPr/>
         </p:nvSpPr>
         <p:spPr>
           <a:xfrm>
-            <a:off x="3913632" y="2587752"/>
+            <a:off x="658368" y="2587752"/>
             <a:ext cx="457200" cy="237744"/>
           </a:xfrm>
           <a:prstGeom prst="roundRect">
@@ -44339,116 +44240,155 @@
       </p:sp>
       <p:sp>
         <p:nvSpPr>
+          <p:cNvPr id="13" name="Text 11"/>
+          <p:cNvSpPr txBox="1"/>
+          <p:nvPr/>
+        </p:nvSpPr>
+        <p:spPr>
+          <a:xfrm>
+            <a:off x="658368" y="2587752"/>
+            <a:ext cx="457200" cy="237744"/>
+          </a:xfrm>
+          <a:prstGeom prst="rect">
+            <a:avLst/>
+          </a:prstGeom>
+          <a:noFill/>
+          <a:ln/>
+        </p:spPr>
+        <p:txBody>
+          <a:bodyPr wrap="square" lIns="0" tIns="0" rIns="0" bIns="0" rtlCol="0" anchor="ctr"/>
+          <a:lstStyle/>
+          <a:p>
+            <a:pPr algn="ctr" indent="0" marL="0">
+              <a:buNone/>
+            </a:pPr>
+            <a:r>
+              <a:rPr lang="en-US" sz="1300" b="1" dirty="0">
+                <a:solidFill>
+                  <a:srgbClr val="FFFFFF"/>
+                </a:solidFill>
+                <a:latin typeface="Arial" pitchFamily="34" charset="0"/>
+                <a:ea typeface="Arial" pitchFamily="34" charset="-122"/>
+                <a:cs typeface="Arial" pitchFamily="34" charset="-120"/>
+              </a:rPr>
+              <a:t>420</a:t>
+            </a:r>
+            <a:endParaRPr lang="en-US" sz="1300" dirty="0"/>
+          </a:p>
+        </p:txBody>
+      </p:sp>
+      <p:sp>
+        <p:nvSpPr>
           <p:cNvPr id="14" name="Text 12"/>
           <p:cNvSpPr txBox="1"/>
           <p:nvPr/>
         </p:nvSpPr>
         <p:spPr>
           <a:xfrm>
-            <a:off x="3913632" y="2587752"/>
-            <a:ext cx="457200" cy="237744"/>
-          </a:xfrm>
-          <a:prstGeom prst="rect">
-            <a:avLst/>
-          </a:prstGeom>
-          <a:noFill/>
-          <a:ln/>
-        </p:spPr>
-        <p:txBody>
-          <a:bodyPr wrap="square" lIns="0" tIns="0" rIns="0" bIns="0" rtlCol="0" anchor="ctr"/>
-          <a:lstStyle/>
-          <a:p>
-            <a:pPr algn="ctr" indent="0" marL="0">
-              <a:buNone/>
-            </a:pPr>
-            <a:r>
-              <a:rPr lang="en-US" sz="1300" b="1" dirty="0">
-                <a:solidFill>
-                  <a:srgbClr val="FFFFFF"/>
-                </a:solidFill>
-                <a:latin typeface="Arial" pitchFamily="34" charset="0"/>
-                <a:ea typeface="Arial" pitchFamily="34" charset="-122"/>
-                <a:cs typeface="Arial" pitchFamily="34" charset="-120"/>
-              </a:rPr>
-              <a:t>420</a:t>
-            </a:r>
-            <a:endParaRPr lang="en-US" sz="1300" dirty="0"/>
-          </a:p>
-        </p:txBody>
-      </p:sp>
-      <p:sp>
-        <p:nvSpPr>
-          <p:cNvPr id="15" name="Text 13"/>
-          <p:cNvSpPr txBox="1"/>
-          <p:nvPr/>
-        </p:nvSpPr>
-        <p:spPr>
-          <a:xfrm>
-            <a:off x="4498848" y="2578608"/>
-            <a:ext cx="6949440" cy="256032"/>
-          </a:xfrm>
-          <a:prstGeom prst="rect">
-            <a:avLst/>
-          </a:prstGeom>
-          <a:noFill/>
-          <a:ln/>
-        </p:spPr>
-        <p:txBody>
-          <a:bodyPr wrap="square" lIns="0" tIns="0" rIns="0" bIns="0" rtlCol="0" anchor="ctr"/>
-          <a:lstStyle/>
-          <a:p>
-            <a:pPr indent="0" marL="0">
-              <a:buNone/>
-            </a:pPr>
-            <a:r>
-              <a:rPr lang="en-US" sz="1000" dirty="0">
-                <a:solidFill>
-                  <a:srgbClr val="24272A"/>
-                </a:solidFill>
-                <a:latin typeface="Arial" pitchFamily="34" charset="0"/>
-                <a:ea typeface="Arial" pitchFamily="34" charset="-122"/>
-                <a:cs typeface="Arial" pitchFamily="34" charset="-120"/>
-              </a:rPr>
-              <a:t>Controller words in the OS text; the last segment is then stripped whatever it is.</a:t>
-            </a:r>
-            <a:endParaRPr lang="en-US" sz="1000" dirty="0"/>
-          </a:p>
-        </p:txBody>
-      </p:sp>
-      <p:sp>
-        <p:nvSpPr>
-          <p:cNvPr id="16" name="Text 14"/>
-          <p:cNvSpPr txBox="1"/>
-          <p:nvPr/>
-        </p:nvSpPr>
-        <p:spPr>
-          <a:xfrm>
-            <a:off x="658368" y="2852928"/>
-            <a:ext cx="10789920" cy="237744"/>
-          </a:xfrm>
-          <a:prstGeom prst="rect">
-            <a:avLst/>
-          </a:prstGeom>
-          <a:noFill/>
-          <a:ln/>
-        </p:spPr>
-        <p:txBody>
-          <a:bodyPr wrap="square" lIns="0" tIns="0" rIns="0" bIns="0" rtlCol="0" anchor="ctr"/>
-          <a:lstStyle/>
-          <a:p>
-            <a:pPr indent="0" marL="0">
-              <a:buNone/>
-            </a:pPr>
-            <a:r>
-              <a:rPr lang="en-US" sz="900" dirty="0">
-                <a:solidFill>
-                  <a:srgbClr val="6B7177"/>
+            <a:off x="1243584" y="2578608"/>
+            <a:ext cx="2377440" cy="256032"/>
+          </a:xfrm>
+          <a:prstGeom prst="rect">
+            <a:avLst/>
+          </a:prstGeom>
+          <a:noFill/>
+          <a:ln/>
+        </p:spPr>
+        <p:txBody>
+          <a:bodyPr wrap="square" lIns="0" tIns="0" rIns="0" bIns="0" rtlCol="0" anchor="ctr"/>
+          <a:lstStyle/>
+          <a:p>
+            <a:pPr indent="0" marL="0">
+              <a:buNone/>
+            </a:pPr>
+            <a:r>
+              <a:rPr lang="en-US" sz="1000" b="1" dirty="0">
+                <a:solidFill>
+                  <a:srgbClr val="E31837"/>
                 </a:solidFill>
                 <a:latin typeface="Courier New" pitchFamily="34" charset="0"/>
                 <a:ea typeface="Courier New" pitchFamily="34" charset="-122"/>
                 <a:cs typeface="Courier New" pitchFamily="34" charset="-120"/>
               </a:rPr>
-              <a:t>ilo, ilom, idrac, drac, remote access controller, imm, cimc, bmc, ipmi, lights out</a:t>
+              <a:t>var markers</a:t>
+            </a:r>
+            <a:endParaRPr lang="en-US" sz="1000" dirty="0"/>
+          </a:p>
+        </p:txBody>
+      </p:sp>
+      <p:sp>
+        <p:nvSpPr>
+          <p:cNvPr id="15" name="Text 13"/>
+          <p:cNvSpPr txBox="1"/>
+          <p:nvPr/>
+        </p:nvSpPr>
+        <p:spPr>
+          <a:xfrm>
+            <a:off x="3749040" y="2578608"/>
+            <a:ext cx="7680960" cy="256032"/>
+          </a:xfrm>
+          <a:prstGeom prst="rect">
+            <a:avLst/>
+          </a:prstGeom>
+          <a:noFill/>
+          <a:ln/>
+        </p:spPr>
+        <p:txBody>
+          <a:bodyPr wrap="square" lIns="0" tIns="0" rIns="0" bIns="0" rtlCol="0" anchor="ctr"/>
+          <a:lstStyle/>
+          <a:p>
+            <a:pPr indent="0" marL="0">
+              <a:buNone/>
+            </a:pPr>
+            <a:r>
+              <a:rPr lang="en-US" sz="1000" dirty="0">
+                <a:solidFill>
+                  <a:srgbClr val="24272A"/>
+                </a:solidFill>
+                <a:latin typeface="Arial" pitchFamily="34" charset="0"/>
+                <a:ea typeface="Arial" pitchFamily="34" charset="-122"/>
+                <a:cs typeface="Arial" pitchFamily="34" charset="-120"/>
+              </a:rPr>
+              <a:t>Controller words in the OS text; the last segment is then stripped whatever it is.</a:t>
+            </a:r>
+            <a:endParaRPr lang="en-US" sz="1000" dirty="0"/>
+          </a:p>
+        </p:txBody>
+      </p:sp>
+      <p:sp>
+        <p:nvSpPr>
+          <p:cNvPr id="16" name="Text 14"/>
+          <p:cNvSpPr txBox="1"/>
+          <p:nvPr/>
+        </p:nvSpPr>
+        <p:spPr>
+          <a:xfrm>
+            <a:off x="1243584" y="2852928"/>
+            <a:ext cx="10241280" cy="237744"/>
+          </a:xfrm>
+          <a:prstGeom prst="rect">
+            <a:avLst/>
+          </a:prstGeom>
+          <a:noFill/>
+          <a:ln/>
+        </p:spPr>
+        <p:txBody>
+          <a:bodyPr wrap="square" lIns="0" tIns="0" rIns="0" bIns="0" rtlCol="0" anchor="ctr"/>
+          <a:lstStyle/>
+          <a:p>
+            <a:pPr indent="0" marL="0">
+              <a:buNone/>
+            </a:pPr>
+            <a:r>
+              <a:rPr lang="en-US" sz="900" dirty="0">
+                <a:solidFill>
+                  <a:srgbClr val="6B7177"/>
+                </a:solidFill>
+                <a:latin typeface="Courier New" pitchFamily="34" charset="0"/>
+                <a:ea typeface="Courier New" pitchFamily="34" charset="-122"/>
+                <a:cs typeface="Courier New" pitchFamily="34" charset="-120"/>
+              </a:rPr>
+              <a:t>['ilo', 'ilom', 'idrac', 'drac', 'remote access controller', 'imm', 'cimc', 'bmc', 'ipmi', 'lights out']</a:t>
             </a:r>
             <a:endParaRPr lang="en-US" sz="900" dirty="0"/>
           </a:p>
@@ -44490,52 +44430,13 @@
       </p:sp>
       <p:sp>
         <p:nvSpPr>
-          <p:cNvPr id="18" name="Text 16"/>
-          <p:cNvSpPr txBox="1"/>
-          <p:nvPr/>
-        </p:nvSpPr>
-        <p:spPr>
-          <a:xfrm>
-            <a:off x="658368" y="3291840"/>
-            <a:ext cx="3200400" cy="256032"/>
-          </a:xfrm>
-          <a:prstGeom prst="rect">
-            <a:avLst/>
-          </a:prstGeom>
-          <a:noFill/>
-          <a:ln/>
-        </p:spPr>
-        <p:txBody>
-          <a:bodyPr wrap="square" lIns="0" tIns="0" rIns="0" bIns="0" rtlCol="0" anchor="ctr"/>
-          <a:lstStyle/>
-          <a:p>
-            <a:pPr indent="0" marL="0">
-              <a:buNone/>
-            </a:pPr>
-            <a:r>
-              <a:rPr lang="en-US" sz="1000" b="1" dirty="0">
-                <a:solidFill>
-                  <a:srgbClr val="E31837"/>
-                </a:solidFill>
-                <a:latin typeface="Courier New" pitchFamily="34" charset="0"/>
-                <a:ea typeface="Courier New" pitchFamily="34" charset="-122"/>
-                <a:cs typeface="Courier New" pitchFamily="34" charset="-120"/>
-              </a:rPr>
-              <a:t>usem.ci_lookup.interface_domains</a:t>
-            </a:r>
-            <a:endParaRPr lang="en-US" sz="1000" dirty="0"/>
-          </a:p>
-        </p:txBody>
-      </p:sp>
-      <p:sp>
-        <p:nvSpPr>
-          <p:cNvPr id="19" name="Shape 17"/>
+          <p:cNvPr id="18" name="Shape 16"/>
           <p:cNvSpPr/>
           <p:nvPr/>
         </p:nvSpPr>
         <p:spPr>
           <a:xfrm>
-            <a:off x="3913632" y="3300984"/>
+            <a:off x="658368" y="3300984"/>
             <a:ext cx="457200" cy="237744"/>
           </a:xfrm>
           <a:prstGeom prst="roundRect">
@@ -44556,116 +44457,155 @@
       </p:sp>
       <p:sp>
         <p:nvSpPr>
+          <p:cNvPr id="19" name="Text 17"/>
+          <p:cNvSpPr txBox="1"/>
+          <p:nvPr/>
+        </p:nvSpPr>
+        <p:spPr>
+          <a:xfrm>
+            <a:off x="658368" y="3300984"/>
+            <a:ext cx="457200" cy="237744"/>
+          </a:xfrm>
+          <a:prstGeom prst="rect">
+            <a:avLst/>
+          </a:prstGeom>
+          <a:noFill/>
+          <a:ln/>
+        </p:spPr>
+        <p:txBody>
+          <a:bodyPr wrap="square" lIns="0" tIns="0" rIns="0" bIns="0" rtlCol="0" anchor="ctr"/>
+          <a:lstStyle/>
+          <a:p>
+            <a:pPr algn="ctr" indent="0" marL="0">
+              <a:buNone/>
+            </a:pPr>
+            <a:r>
+              <a:rPr lang="en-US" sz="1300" b="1" dirty="0">
+                <a:solidFill>
+                  <a:srgbClr val="FFFFFF"/>
+                </a:solidFill>
+                <a:latin typeface="Arial" pitchFamily="34" charset="0"/>
+                <a:ea typeface="Arial" pitchFamily="34" charset="-122"/>
+                <a:cs typeface="Arial" pitchFamily="34" charset="-120"/>
+              </a:rPr>
+              <a:t>430</a:t>
+            </a:r>
+            <a:endParaRPr lang="en-US" sz="1300" dirty="0"/>
+          </a:p>
+        </p:txBody>
+      </p:sp>
+      <p:sp>
+        <p:nvSpPr>
           <p:cNvPr id="20" name="Text 18"/>
           <p:cNvSpPr txBox="1"/>
           <p:nvPr/>
         </p:nvSpPr>
         <p:spPr>
           <a:xfrm>
-            <a:off x="3913632" y="3300984"/>
-            <a:ext cx="457200" cy="237744"/>
-          </a:xfrm>
-          <a:prstGeom prst="rect">
-            <a:avLst/>
-          </a:prstGeom>
-          <a:noFill/>
-          <a:ln/>
-        </p:spPr>
-        <p:txBody>
-          <a:bodyPr wrap="square" lIns="0" tIns="0" rIns="0" bIns="0" rtlCol="0" anchor="ctr"/>
-          <a:lstStyle/>
-          <a:p>
-            <a:pPr algn="ctr" indent="0" marL="0">
-              <a:buNone/>
-            </a:pPr>
-            <a:r>
-              <a:rPr lang="en-US" sz="1300" b="1" dirty="0">
-                <a:solidFill>
-                  <a:srgbClr val="FFFFFF"/>
-                </a:solidFill>
-                <a:latin typeface="Arial" pitchFamily="34" charset="0"/>
-                <a:ea typeface="Arial" pitchFamily="34" charset="-122"/>
-                <a:cs typeface="Arial" pitchFamily="34" charset="-120"/>
-              </a:rPr>
-              <a:t>430</a:t>
-            </a:r>
-            <a:endParaRPr lang="en-US" sz="1300" dirty="0"/>
-          </a:p>
-        </p:txBody>
-      </p:sp>
-      <p:sp>
-        <p:nvSpPr>
-          <p:cNvPr id="21" name="Text 19"/>
-          <p:cNvSpPr txBox="1"/>
-          <p:nvPr/>
-        </p:nvSpPr>
-        <p:spPr>
-          <a:xfrm>
-            <a:off x="4498848" y="3291840"/>
-            <a:ext cx="6949440" cy="256032"/>
-          </a:xfrm>
-          <a:prstGeom prst="rect">
-            <a:avLst/>
-          </a:prstGeom>
-          <a:noFill/>
-          <a:ln/>
-        </p:spPr>
-        <p:txBody>
-          <a:bodyPr wrap="square" lIns="0" tIns="0" rIns="0" bIns="0" rtlCol="0" anchor="ctr"/>
-          <a:lstStyle/>
-          <a:p>
-            <a:pPr indent="0" marL="0">
-              <a:buNone/>
-            </a:pPr>
-            <a:r>
-              <a:rPr lang="en-US" sz="1000" dirty="0">
-                <a:solidFill>
-                  <a:srgbClr val="24272A"/>
-                </a:solidFill>
-                <a:latin typeface="Arial" pitchFamily="34" charset="0"/>
-                <a:ea typeface="Arial" pitchFamily="34" charset="-122"/>
-                <a:cs typeface="Arial" pitchFamily="34" charset="-120"/>
-              </a:rPr>
-              <a:t>DNS domains under which network devices are scanned per interface.</a:t>
-            </a:r>
-            <a:endParaRPr lang="en-US" sz="1000" dirty="0"/>
-          </a:p>
-        </p:txBody>
-      </p:sp>
-      <p:sp>
-        <p:nvSpPr>
-          <p:cNvPr id="22" name="Text 20"/>
-          <p:cNvSpPr txBox="1"/>
-          <p:nvPr/>
-        </p:nvSpPr>
-        <p:spPr>
-          <a:xfrm>
-            <a:off x="658368" y="3566160"/>
-            <a:ext cx="10789920" cy="237744"/>
-          </a:xfrm>
-          <a:prstGeom prst="rect">
-            <a:avLst/>
-          </a:prstGeom>
-          <a:noFill/>
-          <a:ln/>
-        </p:spPr>
-        <p:txBody>
-          <a:bodyPr wrap="square" lIns="0" tIns="0" rIns="0" bIns="0" rtlCol="0" anchor="ctr"/>
-          <a:lstStyle/>
-          <a:p>
-            <a:pPr indent="0" marL="0">
-              <a:buNone/>
-            </a:pPr>
-            <a:r>
-              <a:rPr lang="en-US" sz="900" dirty="0">
-                <a:solidFill>
-                  <a:srgbClr val="6B7177"/>
+            <a:off x="1243584" y="3291840"/>
+            <a:ext cx="2377440" cy="256032"/>
+          </a:xfrm>
+          <a:prstGeom prst="rect">
+            <a:avLst/>
+          </a:prstGeom>
+          <a:noFill/>
+          <a:ln/>
+        </p:spPr>
+        <p:txBody>
+          <a:bodyPr wrap="square" lIns="0" tIns="0" rIns="0" bIns="0" rtlCol="0" anchor="ctr"/>
+          <a:lstStyle/>
+          <a:p>
+            <a:pPr indent="0" marL="0">
+              <a:buNone/>
+            </a:pPr>
+            <a:r>
+              <a:rPr lang="en-US" sz="1000" b="1" dirty="0">
+                <a:solidFill>
+                  <a:srgbClr val="E31837"/>
                 </a:solidFill>
                 <a:latin typeface="Courier New" pitchFamily="34" charset="0"/>
                 <a:ea typeface="Courier New" pitchFamily="34" charset="-122"/>
                 <a:cs typeface="Courier New" pitchFamily="34" charset="-120"/>
               </a:rPr>
-              <a:t>.network.</a:t>
+              <a:t>var domains</a:t>
+            </a:r>
+            <a:endParaRPr lang="en-US" sz="1000" dirty="0"/>
+          </a:p>
+        </p:txBody>
+      </p:sp>
+      <p:sp>
+        <p:nvSpPr>
+          <p:cNvPr id="21" name="Text 19"/>
+          <p:cNvSpPr txBox="1"/>
+          <p:nvPr/>
+        </p:nvSpPr>
+        <p:spPr>
+          <a:xfrm>
+            <a:off x="3749040" y="3291840"/>
+            <a:ext cx="7680960" cy="256032"/>
+          </a:xfrm>
+          <a:prstGeom prst="rect">
+            <a:avLst/>
+          </a:prstGeom>
+          <a:noFill/>
+          <a:ln/>
+        </p:spPr>
+        <p:txBody>
+          <a:bodyPr wrap="square" lIns="0" tIns="0" rIns="0" bIns="0" rtlCol="0" anchor="ctr"/>
+          <a:lstStyle/>
+          <a:p>
+            <a:pPr indent="0" marL="0">
+              <a:buNone/>
+            </a:pPr>
+            <a:r>
+              <a:rPr lang="en-US" sz="1000" dirty="0">
+                <a:solidFill>
+                  <a:srgbClr val="24272A"/>
+                </a:solidFill>
+                <a:latin typeface="Arial" pitchFamily="34" charset="0"/>
+                <a:ea typeface="Arial" pitchFamily="34" charset="-122"/>
+                <a:cs typeface="Arial" pitchFamily="34" charset="-120"/>
+              </a:rPr>
+              <a:t>DNS domains under which network devices are scanned per interface.</a:t>
+            </a:r>
+            <a:endParaRPr lang="en-US" sz="1000" dirty="0"/>
+          </a:p>
+        </p:txBody>
+      </p:sp>
+      <p:sp>
+        <p:nvSpPr>
+          <p:cNvPr id="22" name="Text 20"/>
+          <p:cNvSpPr txBox="1"/>
+          <p:nvPr/>
+        </p:nvSpPr>
+        <p:spPr>
+          <a:xfrm>
+            <a:off x="1243584" y="3566160"/>
+            <a:ext cx="10241280" cy="237744"/>
+          </a:xfrm>
+          <a:prstGeom prst="rect">
+            <a:avLst/>
+          </a:prstGeom>
+          <a:noFill/>
+          <a:ln/>
+        </p:spPr>
+        <p:txBody>
+          <a:bodyPr wrap="square" lIns="0" tIns="0" rIns="0" bIns="0" rtlCol="0" anchor="ctr"/>
+          <a:lstStyle/>
+          <a:p>
+            <a:pPr indent="0" marL="0">
+              <a:buNone/>
+            </a:pPr>
+            <a:r>
+              <a:rPr lang="en-US" sz="900" dirty="0">
+                <a:solidFill>
+                  <a:srgbClr val="6B7177"/>
+                </a:solidFill>
+                <a:latin typeface="Courier New" pitchFamily="34" charset="0"/>
+                <a:ea typeface="Courier New" pitchFamily="34" charset="-122"/>
+                <a:cs typeface="Courier New" pitchFamily="34" charset="-120"/>
+              </a:rPr>
+              <a:t>['.network.']</a:t>
             </a:r>
             <a:endParaRPr lang="en-US" sz="900" dirty="0"/>
           </a:p>
@@ -44707,52 +44647,13 @@
       </p:sp>
       <p:sp>
         <p:nvSpPr>
-          <p:cNvPr id="24" name="Text 22"/>
-          <p:cNvSpPr txBox="1"/>
-          <p:nvPr/>
-        </p:nvSpPr>
-        <p:spPr>
-          <a:xfrm>
-            <a:off x="658368" y="4005072"/>
-            <a:ext cx="3200400" cy="256032"/>
-          </a:xfrm>
-          <a:prstGeom prst="rect">
-            <a:avLst/>
-          </a:prstGeom>
-          <a:noFill/>
-          <a:ln/>
-        </p:spPr>
-        <p:txBody>
-          <a:bodyPr wrap="square" lIns="0" tIns="0" rIns="0" bIns="0" rtlCol="0" anchor="ctr"/>
-          <a:lstStyle/>
-          <a:p>
-            <a:pPr indent="0" marL="0">
-              <a:buNone/>
-            </a:pPr>
-            <a:r>
-              <a:rPr lang="en-US" sz="1000" b="1" dirty="0">
-                <a:solidFill>
-                  <a:srgbClr val="E31837"/>
-                </a:solidFill>
-                <a:latin typeface="Courier New" pitchFamily="34" charset="0"/>
-                <a:ea typeface="Courier New" pitchFamily="34" charset="-122"/>
-                <a:cs typeface="Courier New" pitchFamily="34" charset="-120"/>
-              </a:rPr>
-              <a:t>usem.ci_lookup.interface_markers</a:t>
-            </a:r>
-            <a:endParaRPr lang="en-US" sz="1000" dirty="0"/>
-          </a:p>
-        </p:txBody>
-      </p:sp>
-      <p:sp>
-        <p:nvSpPr>
-          <p:cNvPr id="25" name="Shape 23"/>
+          <p:cNvPr id="24" name="Shape 22"/>
           <p:cNvSpPr/>
           <p:nvPr/>
         </p:nvSpPr>
         <p:spPr>
           <a:xfrm>
-            <a:off x="3913632" y="4014216"/>
+            <a:off x="658368" y="4014216"/>
             <a:ext cx="457200" cy="237744"/>
           </a:xfrm>
           <a:prstGeom prst="roundRect">
@@ -44773,116 +44674,155 @@
       </p:sp>
       <p:sp>
         <p:nvSpPr>
+          <p:cNvPr id="25" name="Text 23"/>
+          <p:cNvSpPr txBox="1"/>
+          <p:nvPr/>
+        </p:nvSpPr>
+        <p:spPr>
+          <a:xfrm>
+            <a:off x="658368" y="4014216"/>
+            <a:ext cx="457200" cy="237744"/>
+          </a:xfrm>
+          <a:prstGeom prst="rect">
+            <a:avLst/>
+          </a:prstGeom>
+          <a:noFill/>
+          <a:ln/>
+        </p:spPr>
+        <p:txBody>
+          <a:bodyPr wrap="square" lIns="0" tIns="0" rIns="0" bIns="0" rtlCol="0" anchor="ctr"/>
+          <a:lstStyle/>
+          <a:p>
+            <a:pPr algn="ctr" indent="0" marL="0">
+              <a:buNone/>
+            </a:pPr>
+            <a:r>
+              <a:rPr lang="en-US" sz="1300" b="1" dirty="0">
+                <a:solidFill>
+                  <a:srgbClr val="FFFFFF"/>
+                </a:solidFill>
+                <a:latin typeface="Arial" pitchFamily="34" charset="0"/>
+                <a:ea typeface="Arial" pitchFamily="34" charset="-122"/>
+                <a:cs typeface="Arial" pitchFamily="34" charset="-120"/>
+              </a:rPr>
+              <a:t>430</a:t>
+            </a:r>
+            <a:endParaRPr lang="en-US" sz="1300" dirty="0"/>
+          </a:p>
+        </p:txBody>
+      </p:sp>
+      <p:sp>
+        <p:nvSpPr>
           <p:cNvPr id="26" name="Text 24"/>
           <p:cNvSpPr txBox="1"/>
           <p:nvPr/>
         </p:nvSpPr>
         <p:spPr>
           <a:xfrm>
-            <a:off x="3913632" y="4014216"/>
-            <a:ext cx="457200" cy="237744"/>
-          </a:xfrm>
-          <a:prstGeom prst="rect">
-            <a:avLst/>
-          </a:prstGeom>
-          <a:noFill/>
-          <a:ln/>
-        </p:spPr>
-        <p:txBody>
-          <a:bodyPr wrap="square" lIns="0" tIns="0" rIns="0" bIns="0" rtlCol="0" anchor="ctr"/>
-          <a:lstStyle/>
-          <a:p>
-            <a:pPr algn="ctr" indent="0" marL="0">
-              <a:buNone/>
-            </a:pPr>
-            <a:r>
-              <a:rPr lang="en-US" sz="1300" b="1" dirty="0">
-                <a:solidFill>
-                  <a:srgbClr val="FFFFFF"/>
-                </a:solidFill>
-                <a:latin typeface="Arial" pitchFamily="34" charset="0"/>
-                <a:ea typeface="Arial" pitchFamily="34" charset="-122"/>
-                <a:cs typeface="Arial" pitchFamily="34" charset="-120"/>
-              </a:rPr>
-              <a:t>430</a:t>
-            </a:r>
-            <a:endParaRPr lang="en-US" sz="1300" dirty="0"/>
-          </a:p>
-        </p:txBody>
-      </p:sp>
-      <p:sp>
-        <p:nvSpPr>
-          <p:cNvPr id="27" name="Text 25"/>
-          <p:cNvSpPr txBox="1"/>
-          <p:nvPr/>
-        </p:nvSpPr>
-        <p:spPr>
-          <a:xfrm>
-            <a:off x="4498848" y="4005072"/>
-            <a:ext cx="6949440" cy="256032"/>
-          </a:xfrm>
-          <a:prstGeom prst="rect">
-            <a:avLst/>
-          </a:prstGeom>
-          <a:noFill/>
-          <a:ln/>
-        </p:spPr>
-        <p:txBody>
-          <a:bodyPr wrap="square" lIns="0" tIns="0" rIns="0" bIns="0" rtlCol="0" anchor="ctr"/>
-          <a:lstStyle/>
-          <a:p>
-            <a:pPr indent="0" marL="0">
-              <a:buNone/>
-            </a:pPr>
-            <a:r>
-              <a:rPr lang="en-US" sz="1000" dirty="0">
-                <a:solidFill>
-                  <a:srgbClr val="24272A"/>
-                </a:solidFill>
-                <a:latin typeface="Arial" pitchFamily="34" charset="0"/>
-                <a:ea typeface="Arial" pitchFamily="34" charset="-122"/>
-                <a:cs typeface="Arial" pitchFamily="34" charset="-120"/>
-              </a:rPr>
-              <a:t>Label segments that mark an interface or VLAN address.</a:t>
-            </a:r>
-            <a:endParaRPr lang="en-US" sz="1000" dirty="0"/>
-          </a:p>
-        </p:txBody>
-      </p:sp>
-      <p:sp>
-        <p:nvSpPr>
-          <p:cNvPr id="28" name="Text 26"/>
-          <p:cNvSpPr txBox="1"/>
-          <p:nvPr/>
-        </p:nvSpPr>
-        <p:spPr>
-          <a:xfrm>
-            <a:off x="658368" y="4279392"/>
-            <a:ext cx="10789920" cy="237744"/>
-          </a:xfrm>
-          <a:prstGeom prst="rect">
-            <a:avLst/>
-          </a:prstGeom>
-          <a:noFill/>
-          <a:ln/>
-        </p:spPr>
-        <p:txBody>
-          <a:bodyPr wrap="square" lIns="0" tIns="0" rIns="0" bIns="0" rtlCol="0" anchor="ctr"/>
-          <a:lstStyle/>
-          <a:p>
-            <a:pPr indent="0" marL="0">
-              <a:buNone/>
-            </a:pPr>
-            <a:r>
-              <a:rPr lang="en-US" sz="900" dirty="0">
-                <a:solidFill>
-                  <a:srgbClr val="6B7177"/>
+            <a:off x="1243584" y="4005072"/>
+            <a:ext cx="2377440" cy="256032"/>
+          </a:xfrm>
+          <a:prstGeom prst="rect">
+            <a:avLst/>
+          </a:prstGeom>
+          <a:noFill/>
+          <a:ln/>
+        </p:spPr>
+        <p:txBody>
+          <a:bodyPr wrap="square" lIns="0" tIns="0" rIns="0" bIns="0" rtlCol="0" anchor="ctr"/>
+          <a:lstStyle/>
+          <a:p>
+            <a:pPr indent="0" marL="0">
+              <a:buNone/>
+            </a:pPr>
+            <a:r>
+              <a:rPr lang="en-US" sz="1000" b="1" dirty="0">
+                <a:solidFill>
+                  <a:srgbClr val="E31837"/>
                 </a:solidFill>
                 <a:latin typeface="Courier New" pitchFamily="34" charset="0"/>
                 <a:ea typeface="Courier New" pitchFamily="34" charset="-122"/>
                 <a:cs typeface="Courier New" pitchFamily="34" charset="-120"/>
               </a:rPr>
-              <a:t>vlan, v, hsrp, vrrp, po, eth, gi, te, lo, mgmt, aom, vs, fab</a:t>
+              <a:t>var markers</a:t>
+            </a:r>
+            <a:endParaRPr lang="en-US" sz="1000" dirty="0"/>
+          </a:p>
+        </p:txBody>
+      </p:sp>
+      <p:sp>
+        <p:nvSpPr>
+          <p:cNvPr id="27" name="Text 25"/>
+          <p:cNvSpPr txBox="1"/>
+          <p:nvPr/>
+        </p:nvSpPr>
+        <p:spPr>
+          <a:xfrm>
+            <a:off x="3749040" y="4005072"/>
+            <a:ext cx="7680960" cy="256032"/>
+          </a:xfrm>
+          <a:prstGeom prst="rect">
+            <a:avLst/>
+          </a:prstGeom>
+          <a:noFill/>
+          <a:ln/>
+        </p:spPr>
+        <p:txBody>
+          <a:bodyPr wrap="square" lIns="0" tIns="0" rIns="0" bIns="0" rtlCol="0" anchor="ctr"/>
+          <a:lstStyle/>
+          <a:p>
+            <a:pPr indent="0" marL="0">
+              <a:buNone/>
+            </a:pPr>
+            <a:r>
+              <a:rPr lang="en-US" sz="1000" dirty="0">
+                <a:solidFill>
+                  <a:srgbClr val="24272A"/>
+                </a:solidFill>
+                <a:latin typeface="Arial" pitchFamily="34" charset="0"/>
+                <a:ea typeface="Arial" pitchFamily="34" charset="-122"/>
+                <a:cs typeface="Arial" pitchFamily="34" charset="-120"/>
+              </a:rPr>
+              <a:t>Label segments that mark an interface or VLAN address.</a:t>
+            </a:r>
+            <a:endParaRPr lang="en-US" sz="1000" dirty="0"/>
+          </a:p>
+        </p:txBody>
+      </p:sp>
+      <p:sp>
+        <p:nvSpPr>
+          <p:cNvPr id="28" name="Text 26"/>
+          <p:cNvSpPr txBox="1"/>
+          <p:nvPr/>
+        </p:nvSpPr>
+        <p:spPr>
+          <a:xfrm>
+            <a:off x="1243584" y="4279392"/>
+            <a:ext cx="10241280" cy="237744"/>
+          </a:xfrm>
+          <a:prstGeom prst="rect">
+            <a:avLst/>
+          </a:prstGeom>
+          <a:noFill/>
+          <a:ln/>
+        </p:spPr>
+        <p:txBody>
+          <a:bodyPr wrap="square" lIns="0" tIns="0" rIns="0" bIns="0" rtlCol="0" anchor="ctr"/>
+          <a:lstStyle/>
+          <a:p>
+            <a:pPr indent="0" marL="0">
+              <a:buNone/>
+            </a:pPr>
+            <a:r>
+              <a:rPr lang="en-US" sz="900" dirty="0">
+                <a:solidFill>
+                  <a:srgbClr val="6B7177"/>
+                </a:solidFill>
+                <a:latin typeface="Courier New" pitchFamily="34" charset="0"/>
+                <a:ea typeface="Courier New" pitchFamily="34" charset="-122"/>
+                <a:cs typeface="Courier New" pitchFamily="34" charset="-120"/>
+              </a:rPr>
+              <a:t>['vlan', 'v', 'hsrp', 'vrrp', 'po', 'eth', 'gi', 'te', 'lo', 'mgmt', 'aom', 'vs', 'fab']</a:t>
             </a:r>
             <a:endParaRPr lang="en-US" sz="900" dirty="0"/>
           </a:p>
@@ -44924,52 +44864,13 @@
       </p:sp>
       <p:sp>
         <p:nvSpPr>
-          <p:cNvPr id="30" name="Text 28"/>
-          <p:cNvSpPr txBox="1"/>
-          <p:nvPr/>
-        </p:nvSpPr>
-        <p:spPr>
-          <a:xfrm>
-            <a:off x="658368" y="4718304"/>
-            <a:ext cx="3200400" cy="256032"/>
-          </a:xfrm>
-          <a:prstGeom prst="rect">
-            <a:avLst/>
-          </a:prstGeom>
-          <a:noFill/>
-          <a:ln/>
-        </p:spPr>
-        <p:txBody>
-          <a:bodyPr wrap="square" lIns="0" tIns="0" rIns="0" bIns="0" rtlCol="0" anchor="ctr"/>
-          <a:lstStyle/>
-          <a:p>
-            <a:pPr indent="0" marL="0">
-              <a:buNone/>
-            </a:pPr>
-            <a:r>
-              <a:rPr lang="en-US" sz="1000" b="1" dirty="0">
-                <a:solidFill>
-                  <a:srgbClr val="E31837"/>
-                </a:solidFill>
-                <a:latin typeface="Courier New" pitchFamily="34" charset="0"/>
-                <a:ea typeface="Courier New" pitchFamily="34" charset="-122"/>
-                <a:cs typeface="Courier New" pitchFamily="34" charset="-120"/>
-              </a:rPr>
-              <a:t>usem.ci_lookup.vip_os_markers</a:t>
-            </a:r>
-            <a:endParaRPr lang="en-US" sz="1000" dirty="0"/>
-          </a:p>
-        </p:txBody>
-      </p:sp>
-      <p:sp>
-        <p:nvSpPr>
-          <p:cNvPr id="31" name="Shape 29"/>
+          <p:cNvPr id="30" name="Shape 28"/>
           <p:cNvSpPr/>
           <p:nvPr/>
         </p:nvSpPr>
         <p:spPr>
           <a:xfrm>
-            <a:off x="3913632" y="4727448"/>
+            <a:off x="658368" y="4727448"/>
             <a:ext cx="457200" cy="237744"/>
           </a:xfrm>
           <a:prstGeom prst="roundRect">
@@ -44990,116 +44891,155 @@
       </p:sp>
       <p:sp>
         <p:nvSpPr>
+          <p:cNvPr id="31" name="Text 29"/>
+          <p:cNvSpPr txBox="1"/>
+          <p:nvPr/>
+        </p:nvSpPr>
+        <p:spPr>
+          <a:xfrm>
+            <a:off x="658368" y="4727448"/>
+            <a:ext cx="457200" cy="237744"/>
+          </a:xfrm>
+          <a:prstGeom prst="rect">
+            <a:avLst/>
+          </a:prstGeom>
+          <a:noFill/>
+          <a:ln/>
+        </p:spPr>
+        <p:txBody>
+          <a:bodyPr wrap="square" lIns="0" tIns="0" rIns="0" bIns="0" rtlCol="0" anchor="ctr"/>
+          <a:lstStyle/>
+          <a:p>
+            <a:pPr algn="ctr" indent="0" marL="0">
+              <a:buNone/>
+            </a:pPr>
+            <a:r>
+              <a:rPr lang="en-US" sz="1300" b="1" dirty="0">
+                <a:solidFill>
+                  <a:srgbClr val="FFFFFF"/>
+                </a:solidFill>
+                <a:latin typeface="Arial" pitchFamily="34" charset="0"/>
+                <a:ea typeface="Arial" pitchFamily="34" charset="-122"/>
+                <a:cs typeface="Arial" pitchFamily="34" charset="-120"/>
+              </a:rPr>
+              <a:t>460</a:t>
+            </a:r>
+            <a:endParaRPr lang="en-US" sz="1300" dirty="0"/>
+          </a:p>
+        </p:txBody>
+      </p:sp>
+      <p:sp>
+        <p:nvSpPr>
           <p:cNvPr id="32" name="Text 30"/>
           <p:cNvSpPr txBox="1"/>
           <p:nvPr/>
         </p:nvSpPr>
         <p:spPr>
           <a:xfrm>
-            <a:off x="3913632" y="4727448"/>
-            <a:ext cx="457200" cy="237744"/>
-          </a:xfrm>
-          <a:prstGeom prst="rect">
-            <a:avLst/>
-          </a:prstGeom>
-          <a:noFill/>
-          <a:ln/>
-        </p:spPr>
-        <p:txBody>
-          <a:bodyPr wrap="square" lIns="0" tIns="0" rIns="0" bIns="0" rtlCol="0" anchor="ctr"/>
-          <a:lstStyle/>
-          <a:p>
-            <a:pPr algn="ctr" indent="0" marL="0">
-              <a:buNone/>
-            </a:pPr>
-            <a:r>
-              <a:rPr lang="en-US" sz="1300" b="1" dirty="0">
-                <a:solidFill>
-                  <a:srgbClr val="FFFFFF"/>
-                </a:solidFill>
-                <a:latin typeface="Arial" pitchFamily="34" charset="0"/>
-                <a:ea typeface="Arial" pitchFamily="34" charset="-122"/>
-                <a:cs typeface="Arial" pitchFamily="34" charset="-120"/>
-              </a:rPr>
-              <a:t>460</a:t>
-            </a:r>
-            <a:endParaRPr lang="en-US" sz="1300" dirty="0"/>
-          </a:p>
-        </p:txBody>
-      </p:sp>
-      <p:sp>
-        <p:nvSpPr>
-          <p:cNvPr id="33" name="Text 31"/>
-          <p:cNvSpPr txBox="1"/>
-          <p:nvPr/>
-        </p:nvSpPr>
-        <p:spPr>
-          <a:xfrm>
-            <a:off x="4498848" y="4718304"/>
-            <a:ext cx="6949440" cy="256032"/>
-          </a:xfrm>
-          <a:prstGeom prst="rect">
-            <a:avLst/>
-          </a:prstGeom>
-          <a:noFill/>
-          <a:ln/>
-        </p:spPr>
-        <p:txBody>
-          <a:bodyPr wrap="square" lIns="0" tIns="0" rIns="0" bIns="0" rtlCol="0" anchor="ctr"/>
-          <a:lstStyle/>
-          <a:p>
-            <a:pPr indent="0" marL="0">
-              <a:buNone/>
-            </a:pPr>
-            <a:r>
-              <a:rPr lang="en-US" sz="1000" dirty="0">
-                <a:solidFill>
-                  <a:srgbClr val="24272A"/>
-                </a:solidFill>
-                <a:latin typeface="Arial" pitchFamily="34" charset="0"/>
-                <a:ea typeface="Arial" pitchFamily="34" charset="-122"/>
-                <a:cs typeface="Arial" pitchFamily="34" charset="-120"/>
-              </a:rPr>
-              <a:t>Load balancer products in the OS text.</a:t>
-            </a:r>
-            <a:endParaRPr lang="en-US" sz="1000" dirty="0"/>
-          </a:p>
-        </p:txBody>
-      </p:sp>
-      <p:sp>
-        <p:nvSpPr>
-          <p:cNvPr id="34" name="Text 32"/>
-          <p:cNvSpPr txBox="1"/>
-          <p:nvPr/>
-        </p:nvSpPr>
-        <p:spPr>
-          <a:xfrm>
-            <a:off x="658368" y="4992624"/>
-            <a:ext cx="10789920" cy="237744"/>
-          </a:xfrm>
-          <a:prstGeom prst="rect">
-            <a:avLst/>
-          </a:prstGeom>
-          <a:noFill/>
-          <a:ln/>
-        </p:spPr>
-        <p:txBody>
-          <a:bodyPr wrap="square" lIns="0" tIns="0" rIns="0" bIns="0" rtlCol="0" anchor="ctr"/>
-          <a:lstStyle/>
-          <a:p>
-            <a:pPr indent="0" marL="0">
-              <a:buNone/>
-            </a:pPr>
-            <a:r>
-              <a:rPr lang="en-US" sz="900" dirty="0">
-                <a:solidFill>
-                  <a:srgbClr val="6B7177"/>
+            <a:off x="1243584" y="4718304"/>
+            <a:ext cx="2377440" cy="256032"/>
+          </a:xfrm>
+          <a:prstGeom prst="rect">
+            <a:avLst/>
+          </a:prstGeom>
+          <a:noFill/>
+          <a:ln/>
+        </p:spPr>
+        <p:txBody>
+          <a:bodyPr wrap="square" lIns="0" tIns="0" rIns="0" bIns="0" rtlCol="0" anchor="ctr"/>
+          <a:lstStyle/>
+          <a:p>
+            <a:pPr indent="0" marL="0">
+              <a:buNone/>
+            </a:pPr>
+            <a:r>
+              <a:rPr lang="en-US" sz="1000" b="1" dirty="0">
+                <a:solidFill>
+                  <a:srgbClr val="E31837"/>
                 </a:solidFill>
                 <a:latin typeface="Courier New" pitchFamily="34" charset="0"/>
                 <a:ea typeface="Courier New" pitchFamily="34" charset="-122"/>
                 <a:cs typeface="Courier New" pitchFamily="34" charset="-120"/>
               </a:rPr>
-              <a:t>f5, big-ip, big ip, netscaler</a:t>
+              <a:t>var osMarkers</a:t>
+            </a:r>
+            <a:endParaRPr lang="en-US" sz="1000" dirty="0"/>
+          </a:p>
+        </p:txBody>
+      </p:sp>
+      <p:sp>
+        <p:nvSpPr>
+          <p:cNvPr id="33" name="Text 31"/>
+          <p:cNvSpPr txBox="1"/>
+          <p:nvPr/>
+        </p:nvSpPr>
+        <p:spPr>
+          <a:xfrm>
+            <a:off x="3749040" y="4718304"/>
+            <a:ext cx="7680960" cy="256032"/>
+          </a:xfrm>
+          <a:prstGeom prst="rect">
+            <a:avLst/>
+          </a:prstGeom>
+          <a:noFill/>
+          <a:ln/>
+        </p:spPr>
+        <p:txBody>
+          <a:bodyPr wrap="square" lIns="0" tIns="0" rIns="0" bIns="0" rtlCol="0" anchor="ctr"/>
+          <a:lstStyle/>
+          <a:p>
+            <a:pPr indent="0" marL="0">
+              <a:buNone/>
+            </a:pPr>
+            <a:r>
+              <a:rPr lang="en-US" sz="1000" dirty="0">
+                <a:solidFill>
+                  <a:srgbClr val="24272A"/>
+                </a:solidFill>
+                <a:latin typeface="Arial" pitchFamily="34" charset="0"/>
+                <a:ea typeface="Arial" pitchFamily="34" charset="-122"/>
+                <a:cs typeface="Arial" pitchFamily="34" charset="-120"/>
+              </a:rPr>
+              <a:t>Load balancer products in the OS text.</a:t>
+            </a:r>
+            <a:endParaRPr lang="en-US" sz="1000" dirty="0"/>
+          </a:p>
+        </p:txBody>
+      </p:sp>
+      <p:sp>
+        <p:nvSpPr>
+          <p:cNvPr id="34" name="Text 32"/>
+          <p:cNvSpPr txBox="1"/>
+          <p:nvPr/>
+        </p:nvSpPr>
+        <p:spPr>
+          <a:xfrm>
+            <a:off x="1243584" y="4992624"/>
+            <a:ext cx="10241280" cy="237744"/>
+          </a:xfrm>
+          <a:prstGeom prst="rect">
+            <a:avLst/>
+          </a:prstGeom>
+          <a:noFill/>
+          <a:ln/>
+        </p:spPr>
+        <p:txBody>
+          <a:bodyPr wrap="square" lIns="0" tIns="0" rIns="0" bIns="0" rtlCol="0" anchor="ctr"/>
+          <a:lstStyle/>
+          <a:p>
+            <a:pPr indent="0" marL="0">
+              <a:buNone/>
+            </a:pPr>
+            <a:r>
+              <a:rPr lang="en-US" sz="900" dirty="0">
+                <a:solidFill>
+                  <a:srgbClr val="6B7177"/>
+                </a:solidFill>
+                <a:latin typeface="Courier New" pitchFamily="34" charset="0"/>
+                <a:ea typeface="Courier New" pitchFamily="34" charset="-122"/>
+                <a:cs typeface="Courier New" pitchFamily="34" charset="-120"/>
+              </a:rPr>
+              <a:t>['f5', 'big-ip', 'big ip', 'netscaler']</a:t>
             </a:r>
             <a:endParaRPr lang="en-US" sz="900" dirty="0"/>
           </a:p>
@@ -45141,52 +45081,13 @@
       </p:sp>
       <p:sp>
         <p:nvSpPr>
-          <p:cNvPr id="36" name="Text 34"/>
-          <p:cNvSpPr txBox="1"/>
-          <p:nvPr/>
-        </p:nvSpPr>
-        <p:spPr>
-          <a:xfrm>
-            <a:off x="658368" y="5431536"/>
-            <a:ext cx="3200400" cy="256032"/>
-          </a:xfrm>
-          <a:prstGeom prst="rect">
-            <a:avLst/>
-          </a:prstGeom>
-          <a:noFill/>
-          <a:ln/>
-        </p:spPr>
-        <p:txBody>
-          <a:bodyPr wrap="square" lIns="0" tIns="0" rIns="0" bIns="0" rtlCol="0" anchor="ctr"/>
-          <a:lstStyle/>
-          <a:p>
-            <a:pPr indent="0" marL="0">
-              <a:buNone/>
-            </a:pPr>
-            <a:r>
-              <a:rPr lang="en-US" sz="1000" b="1" dirty="0">
-                <a:solidFill>
-                  <a:srgbClr val="E31837"/>
-                </a:solidFill>
-                <a:latin typeface="Courier New" pitchFamily="34" charset="0"/>
-                <a:ea typeface="Courier New" pitchFamily="34" charset="-122"/>
-                <a:cs typeface="Courier New" pitchFamily="34" charset="-120"/>
-              </a:rPr>
-              <a:t>usem.ci_lookup.vip_markers</a:t>
-            </a:r>
-            <a:endParaRPr lang="en-US" sz="1000" dirty="0"/>
-          </a:p>
-        </p:txBody>
-      </p:sp>
-      <p:sp>
-        <p:nvSpPr>
-          <p:cNvPr id="37" name="Shape 35"/>
+          <p:cNvPr id="36" name="Shape 34"/>
           <p:cNvSpPr/>
           <p:nvPr/>
         </p:nvSpPr>
         <p:spPr>
           <a:xfrm>
-            <a:off x="3913632" y="5440680"/>
+            <a:off x="658368" y="5440680"/>
             <a:ext cx="457200" cy="237744"/>
           </a:xfrm>
           <a:prstGeom prst="roundRect">
@@ -45207,116 +45108,155 @@
       </p:sp>
       <p:sp>
         <p:nvSpPr>
+          <p:cNvPr id="37" name="Text 35"/>
+          <p:cNvSpPr txBox="1"/>
+          <p:nvPr/>
+        </p:nvSpPr>
+        <p:spPr>
+          <a:xfrm>
+            <a:off x="658368" y="5440680"/>
+            <a:ext cx="457200" cy="237744"/>
+          </a:xfrm>
+          <a:prstGeom prst="rect">
+            <a:avLst/>
+          </a:prstGeom>
+          <a:noFill/>
+          <a:ln/>
+        </p:spPr>
+        <p:txBody>
+          <a:bodyPr wrap="square" lIns="0" tIns="0" rIns="0" bIns="0" rtlCol="0" anchor="ctr"/>
+          <a:lstStyle/>
+          <a:p>
+            <a:pPr algn="ctr" indent="0" marL="0">
+              <a:buNone/>
+            </a:pPr>
+            <a:r>
+              <a:rPr lang="en-US" sz="1300" b="1" dirty="0">
+                <a:solidFill>
+                  <a:srgbClr val="FFFFFF"/>
+                </a:solidFill>
+                <a:latin typeface="Arial" pitchFamily="34" charset="0"/>
+                <a:ea typeface="Arial" pitchFamily="34" charset="-122"/>
+                <a:cs typeface="Arial" pitchFamily="34" charset="-120"/>
+              </a:rPr>
+              <a:t>460</a:t>
+            </a:r>
+            <a:endParaRPr lang="en-US" sz="1300" dirty="0"/>
+          </a:p>
+        </p:txBody>
+      </p:sp>
+      <p:sp>
+        <p:nvSpPr>
           <p:cNvPr id="38" name="Text 36"/>
           <p:cNvSpPr txBox="1"/>
           <p:nvPr/>
         </p:nvSpPr>
         <p:spPr>
           <a:xfrm>
-            <a:off x="3913632" y="5440680"/>
-            <a:ext cx="457200" cy="237744"/>
-          </a:xfrm>
-          <a:prstGeom prst="rect">
-            <a:avLst/>
-          </a:prstGeom>
-          <a:noFill/>
-          <a:ln/>
-        </p:spPr>
-        <p:txBody>
-          <a:bodyPr wrap="square" lIns="0" tIns="0" rIns="0" bIns="0" rtlCol="0" anchor="ctr"/>
-          <a:lstStyle/>
-          <a:p>
-            <a:pPr algn="ctr" indent="0" marL="0">
-              <a:buNone/>
-            </a:pPr>
-            <a:r>
-              <a:rPr lang="en-US" sz="1300" b="1" dirty="0">
-                <a:solidFill>
-                  <a:srgbClr val="FFFFFF"/>
-                </a:solidFill>
-                <a:latin typeface="Arial" pitchFamily="34" charset="0"/>
-                <a:ea typeface="Arial" pitchFamily="34" charset="-122"/>
-                <a:cs typeface="Arial" pitchFamily="34" charset="-120"/>
-              </a:rPr>
-              <a:t>460</a:t>
-            </a:r>
-            <a:endParaRPr lang="en-US" sz="1300" dirty="0"/>
-          </a:p>
-        </p:txBody>
-      </p:sp>
-      <p:sp>
-        <p:nvSpPr>
-          <p:cNvPr id="39" name="Text 37"/>
-          <p:cNvSpPr txBox="1"/>
-          <p:nvPr/>
-        </p:nvSpPr>
-        <p:spPr>
-          <a:xfrm>
-            <a:off x="4498848" y="5431536"/>
-            <a:ext cx="6949440" cy="256032"/>
-          </a:xfrm>
-          <a:prstGeom prst="rect">
-            <a:avLst/>
-          </a:prstGeom>
-          <a:noFill/>
-          <a:ln/>
-        </p:spPr>
-        <p:txBody>
-          <a:bodyPr wrap="square" lIns="0" tIns="0" rIns="0" bIns="0" rtlCol="0" anchor="ctr"/>
-          <a:lstStyle/>
-          <a:p>
-            <a:pPr indent="0" marL="0">
-              <a:buNone/>
-            </a:pPr>
-            <a:r>
-              <a:rPr lang="en-US" sz="1000" dirty="0">
-                <a:solidFill>
-                  <a:srgbClr val="24272A"/>
-                </a:solidFill>
-                <a:latin typeface="Arial" pitchFamily="34" charset="0"/>
-                <a:ea typeface="Arial" pitchFamily="34" charset="-122"/>
-                <a:cs typeface="Arial" pitchFamily="34" charset="-120"/>
-              </a:rPr>
-              <a:t>Label segments that mark a virtual IP.</a:t>
-            </a:r>
-            <a:endParaRPr lang="en-US" sz="1000" dirty="0"/>
-          </a:p>
-        </p:txBody>
-      </p:sp>
-      <p:sp>
-        <p:nvSpPr>
-          <p:cNvPr id="40" name="Text 38"/>
-          <p:cNvSpPr txBox="1"/>
-          <p:nvPr/>
-        </p:nvSpPr>
-        <p:spPr>
-          <a:xfrm>
-            <a:off x="658368" y="5705856"/>
-            <a:ext cx="10789920" cy="237744"/>
-          </a:xfrm>
-          <a:prstGeom prst="rect">
-            <a:avLst/>
-          </a:prstGeom>
-          <a:noFill/>
-          <a:ln/>
-        </p:spPr>
-        <p:txBody>
-          <a:bodyPr wrap="square" lIns="0" tIns="0" rIns="0" bIns="0" rtlCol="0" anchor="ctr"/>
-          <a:lstStyle/>
-          <a:p>
-            <a:pPr indent="0" marL="0">
-              <a:buNone/>
-            </a:pPr>
-            <a:r>
-              <a:rPr lang="en-US" sz="900" dirty="0">
-                <a:solidFill>
-                  <a:srgbClr val="6B7177"/>
+            <a:off x="1243584" y="5431536"/>
+            <a:ext cx="2377440" cy="256032"/>
+          </a:xfrm>
+          <a:prstGeom prst="rect">
+            <a:avLst/>
+          </a:prstGeom>
+          <a:noFill/>
+          <a:ln/>
+        </p:spPr>
+        <p:txBody>
+          <a:bodyPr wrap="square" lIns="0" tIns="0" rIns="0" bIns="0" rtlCol="0" anchor="ctr"/>
+          <a:lstStyle/>
+          <a:p>
+            <a:pPr indent="0" marL="0">
+              <a:buNone/>
+            </a:pPr>
+            <a:r>
+              <a:rPr lang="en-US" sz="1000" b="1" dirty="0">
+                <a:solidFill>
+                  <a:srgbClr val="E31837"/>
                 </a:solidFill>
                 <a:latin typeface="Courier New" pitchFamily="34" charset="0"/>
                 <a:ea typeface="Courier New" pitchFamily="34" charset="-122"/>
                 <a:cs typeface="Courier New" pitchFamily="34" charset="-120"/>
               </a:rPr>
-              <a:t>vip, vs</a:t>
+              <a:t>var labelMarkers</a:t>
+            </a:r>
+            <a:endParaRPr lang="en-US" sz="1000" dirty="0"/>
+          </a:p>
+        </p:txBody>
+      </p:sp>
+      <p:sp>
+        <p:nvSpPr>
+          <p:cNvPr id="39" name="Text 37"/>
+          <p:cNvSpPr txBox="1"/>
+          <p:nvPr/>
+        </p:nvSpPr>
+        <p:spPr>
+          <a:xfrm>
+            <a:off x="3749040" y="5431536"/>
+            <a:ext cx="7680960" cy="256032"/>
+          </a:xfrm>
+          <a:prstGeom prst="rect">
+            <a:avLst/>
+          </a:prstGeom>
+          <a:noFill/>
+          <a:ln/>
+        </p:spPr>
+        <p:txBody>
+          <a:bodyPr wrap="square" lIns="0" tIns="0" rIns="0" bIns="0" rtlCol="0" anchor="ctr"/>
+          <a:lstStyle/>
+          <a:p>
+            <a:pPr indent="0" marL="0">
+              <a:buNone/>
+            </a:pPr>
+            <a:r>
+              <a:rPr lang="en-US" sz="1000" dirty="0">
+                <a:solidFill>
+                  <a:srgbClr val="24272A"/>
+                </a:solidFill>
+                <a:latin typeface="Arial" pitchFamily="34" charset="0"/>
+                <a:ea typeface="Arial" pitchFamily="34" charset="-122"/>
+                <a:cs typeface="Arial" pitchFamily="34" charset="-120"/>
+              </a:rPr>
+              <a:t>Label segments that mark a virtual IP.</a:t>
+            </a:r>
+            <a:endParaRPr lang="en-US" sz="1000" dirty="0"/>
+          </a:p>
+        </p:txBody>
+      </p:sp>
+      <p:sp>
+        <p:nvSpPr>
+          <p:cNvPr id="40" name="Text 38"/>
+          <p:cNvSpPr txBox="1"/>
+          <p:nvPr/>
+        </p:nvSpPr>
+        <p:spPr>
+          <a:xfrm>
+            <a:off x="1243584" y="5705856"/>
+            <a:ext cx="10241280" cy="237744"/>
+          </a:xfrm>
+          <a:prstGeom prst="rect">
+            <a:avLst/>
+          </a:prstGeom>
+          <a:noFill/>
+          <a:ln/>
+        </p:spPr>
+        <p:txBody>
+          <a:bodyPr wrap="square" lIns="0" tIns="0" rIns="0" bIns="0" rtlCol="0" anchor="ctr"/>
+          <a:lstStyle/>
+          <a:p>
+            <a:pPr indent="0" marL="0">
+              <a:buNone/>
+            </a:pPr>
+            <a:r>
+              <a:rPr lang="en-US" sz="900" dirty="0">
+                <a:solidFill>
+                  <a:srgbClr val="6B7177"/>
+                </a:solidFill>
+                <a:latin typeface="Courier New" pitchFamily="34" charset="0"/>
+                <a:ea typeface="Courier New" pitchFamily="34" charset="-122"/>
+                <a:cs typeface="Courier New" pitchFamily="34" charset="-120"/>
+              </a:rPr>
+              <a:t>['vip', 'vs']</a:t>
             </a:r>
             <a:endParaRPr lang="en-US" sz="900" dirty="0"/>
           </a:p>
@@ -45389,7 +45329,7 @@
                 <a:ea typeface="Arial" pitchFamily="34" charset="-122"/>
                 <a:cs typeface="Arial" pitchFamily="34" charset="-120"/>
               </a:rPr>
-              <a:t>Adding a site’s naming habit is a property edit, not a code change.  </a:t>
+              <a:t>Changing a list is a change to the rule.  </a:t>
             </a:r>
             <a:pPr indent="0" marL="0">
               <a:buNone/>
@@ -45403,7 +45343,7 @@
                 <a:ea typeface="Arial" pitchFamily="34" charset="-122"/>
                 <a:cs typeface="Arial" pitchFamily="34" charset="-120"/>
               </a:rPr>
-              <a:t>A new controller suffix or VLAN marker is typed into the list; the rule picks it up on the next evaluation, with no update set and no release.</a:t>
+              <a:t>A new controller suffix or VLAN marker is added to the array and the rule ships in the next update set, the same path as any other change to the chain. No system property is created, read or shipped.</a:t>
             </a:r>
             <a:endParaRPr lang="en-US" sz="1100" dirty="0"/>
           </a:p>
@@ -48461,7 +48401,7 @@
                 <a:ea typeface="Arial" pitchFamily="34" charset="-122"/>
                 <a:cs typeface="Arial" pitchFamily="34" charset="-120"/>
               </a:rPr>
-              <a:t>9 updates</a:t>
+              <a:t>3 updates</a:t>
             </a:r>
             <a:endParaRPr lang="en-US" sz="1300" dirty="0"/>
           </a:p>
@@ -48500,7 +48440,7 @@
                 <a:ea typeface="Arial" pitchFamily="34" charset="-122"/>
                 <a:cs typeface="Arial" pitchFamily="34" charset="-120"/>
               </a:rPr>
-              <a:t>Three new rules and their six properties. Applies on top of the first set.</a:t>
+              <a:t>Three new rules, each carrying its own lists. Applies on top of the first set.</a:t>
             </a:r>
             <a:endParaRPr lang="en-US" sz="1100" dirty="0"/>
           </a:p>
@@ -48686,7 +48626,7 @@
                 <a:ea typeface="Arial" pitchFamily="34" charset="-122"/>
                 <a:cs typeface="Arial" pitchFamily="34" charset="-120"/>
               </a:rPr>
-              <a:t>A new controller suffix, VLAN marker or balancer product goes into the matching property. No script edit, no update set.</a:t>
+              <a:t>A new controller suffix, VLAN marker or balancer product is added to the list at the top of the matching stage, and the rule ships in the next update set.</a:t>
             </a:r>
             <a:endParaRPr lang="en-US" sz="1350" dirty="0"/>
           </a:p>
@@ -48872,7 +48812,7 @@
                 <a:ea typeface="Arial" pitchFamily="34" charset="-122"/>
                 <a:cs typeface="Arial" pitchFamily="34" charset="-120"/>
               </a:rPr>
-              <a:t>The matched share of Discovered Items by rule. A rule that suddenly matches far more than its group size is the early sign that a property list has been widened too far.</a:t>
+              <a:t>The matched share of Discovered Items by rule. A rule that suddenly matches far more than its group size is the early sign that a list has been widened too far.</a:t>
             </a:r>
             <a:endParaRPr lang="en-US" sz="1350" dirty="0"/>
           </a:p>
@@ -53427,7 +53367,7 @@
                 <a:ea typeface="Arial" pitchFamily="34" charset="-122"/>
                 <a:cs typeface="Arial" pitchFamily="34" charset="-120"/>
               </a:rPr>
-              <a:t>The vocabularies those rules depend on live in properties, so a naming habit can be added without touching a script.</a:t>
+              <a:t>The vocabularies those rules depend on are declared beside the code that reads them, so nothing outside the rule has to exist for it to run.</a:t>
             </a:r>
             <a:endParaRPr lang="en-US" sz="1300" dirty="0"/>
           </a:p>

</xml_diff>

<commit_message>
Qualys CI lookup rules V3.3: the set now deletes the six former usem.ci_lookup properties alongside the three rules
Co-Authored-By: Claude Fable 5.1 <noreply@anthropic.com>
Claude-Session: https://claude.ai/code/session_01UaiSzs85tKmfaeLA1rAxsP
</commit_message>
<xml_diff>
--- a/stories/qualys-ci-lookup-rules/Qualys CI Lookup Rules - Technical Walkthrough.pptx
+++ b/stories/qualys-ci-lookup-rules/Qualys CI Lookup Rules - Technical Walkthrough.pptx
@@ -48401,7 +48401,7 @@
                 <a:ea typeface="Arial" pitchFamily="34" charset="-122"/>
                 <a:cs typeface="Arial" pitchFamily="34" charset="-120"/>
               </a:rPr>
-              <a:t>3 updates</a:t>
+              <a:t>9 updates</a:t>
             </a:r>
             <a:endParaRPr lang="en-US" sz="1300" dirty="0"/>
           </a:p>
@@ -48440,7 +48440,7 @@
                 <a:ea typeface="Arial" pitchFamily="34" charset="-122"/>
                 <a:cs typeface="Arial" pitchFamily="34" charset="-120"/>
               </a:rPr>
-              <a:t>Three new rules, each carrying its own lists. Applies on top of the first set.</a:t>
+              <a:t>Three new rules, each carrying its own lists, plus the removal of the six properties an earlier cut shipped. Applies on top of the first set.</a:t>
             </a:r>
             <a:endParaRPr lang="en-US" sz="1100" dirty="0"/>
           </a:p>

</xml_diff>